<commit_message>
docs: shrink defense PPT to 7 content pages for Image 2
Keep architecture-only copy, drop Q&A and live-demo scripts, and leave
layout to Image 2. The 4-minute demo is the team's screen recording.
</commit_message>
<xml_diff>
--- a/06_defense/13组-摸鱼-最终答辩.pptx
+++ b/06_defense/13组-摸鱼-最终答辩.pptx
@@ -6,25 +6,14 @@
   </p:sldMasterIdLst>
   <p:sldIdLst>
     <p:sldId id="256" r:id="rId7"/>
-    <p:sldId id="257" r:id="rId9"/>
-    <p:sldId id="258" r:id="rId10"/>
-    <p:sldId id="259" r:id="rId11"/>
-    <p:sldId id="260" r:id="rId12"/>
-    <p:sldId id="261" r:id="rId13"/>
-    <p:sldId id="262" r:id="rId14"/>
-    <p:sldId id="263" r:id="rId15"/>
-    <p:sldId id="264" r:id="rId16"/>
-    <p:sldId id="265" r:id="rId17"/>
-    <p:sldId id="266" r:id="rId18"/>
-    <p:sldId id="267" r:id="rId19"/>
-    <p:sldId id="268" r:id="rId20"/>
-    <p:sldId id="269" r:id="rId21"/>
-    <p:sldId id="270" r:id="rId22"/>
-    <p:sldId id="271" r:id="rId23"/>
-    <p:sldId id="272" r:id="rId24"/>
-    <p:sldId id="273" r:id="rId25"/>
+    <p:sldId id="257" r:id="rId8"/>
+    <p:sldId id="258" r:id="rId9"/>
+    <p:sldId id="259" r:id="rId10"/>
+    <p:sldId id="260" r:id="rId11"/>
+    <p:sldId id="261" r:id="rId12"/>
+    <p:sldId id="262" r:id="rId13"/>
   </p:sldIdLst>
-  <p:sldSz cx="12191999" cy="6858000" type="screen4x3"/>
+  <p:sldSz cx="12191695" cy="6858000" type="screen4x3"/>
   <p:notesSz cx="6858000" cy="9144000"/>
   <p:defaultTextStyle>
     <a:defPPr>
@@ -122,1616 +111,6 @@
     </a:lvl9pPr>
   </p:defaultTextStyle>
 </p:presentation>
-</file>
-
-<file path=ppt/notesMasters/notesMaster1.xml><?xml version="1.0" encoding="utf-8"?>
-<p:notesMaster xmlns:a="http://schemas.openxmlformats.org/drawingml/2006/main" xmlns:p="http://schemas.openxmlformats.org/presentationml/2006/main" xmlns:r="http://schemas.openxmlformats.org/officeDocument/2006/relationships">
-  <p:cSld>
-    <p:bg>
-      <p:bgRef idx="1001">
-        <a:schemeClr val="bg1"/>
-      </p:bgRef>
-    </p:bg>
-    <p:spTree>
-      <p:nvGrpSpPr>
-        <p:cNvPr id="1" name=""/>
-        <p:cNvGrpSpPr/>
-        <p:nvPr/>
-      </p:nvGrpSpPr>
-      <p:grpSpPr>
-        <a:xfrm>
-          <a:off x="0" y="0"/>
-          <a:ext cx="0" cy="0"/>
-          <a:chOff x="0" y="0"/>
-          <a:chExt cx="0" cy="0"/>
-        </a:xfrm>
-      </p:grpSpPr>
-      <p:sp>
-        <p:nvSpPr>
-          <p:cNvPr id="2" name="Header Placeholder 1"/>
-          <p:cNvSpPr>
-            <a:spLocks noGrp="1"/>
-          </p:cNvSpPr>
-          <p:nvPr>
-            <p:ph type="hdr" sz="quarter"/>
-          </p:nvPr>
-        </p:nvSpPr>
-        <p:spPr>
-          <a:xfrm>
-            <a:off x="0" y="0"/>
-            <a:ext cx="2971800" cy="457200"/>
-          </a:xfrm>
-          <a:prstGeom prst="rect">
-            <a:avLst/>
-          </a:prstGeom>
-        </p:spPr>
-        <p:txBody>
-          <a:bodyPr vert="horz" lIns="91440" tIns="45720" rIns="91440" bIns="45720" rtlCol="0"/>
-          <a:lstStyle>
-            <a:lvl1pPr algn="l">
-              <a:defRPr sz="1200"/>
-            </a:lvl1pPr>
-          </a:lstStyle>
-          <a:p>
-            <a:endParaRPr lang="en-US"/>
-          </a:p>
-        </p:txBody>
-      </p:sp>
-      <p:sp>
-        <p:nvSpPr>
-          <p:cNvPr id="3" name="Date Placeholder 2"/>
-          <p:cNvSpPr>
-            <a:spLocks noGrp="1"/>
-          </p:cNvSpPr>
-          <p:nvPr>
-            <p:ph type="dt" idx="1"/>
-          </p:nvPr>
-        </p:nvSpPr>
-        <p:spPr>
-          <a:xfrm>
-            <a:off x="3884613" y="0"/>
-            <a:ext cx="2971800" cy="457200"/>
-          </a:xfrm>
-          <a:prstGeom prst="rect">
-            <a:avLst/>
-          </a:prstGeom>
-        </p:spPr>
-        <p:txBody>
-          <a:bodyPr vert="horz" lIns="91440" tIns="45720" rIns="91440" bIns="45720" rtlCol="0"/>
-          <a:lstStyle>
-            <a:lvl1pPr algn="r">
-              <a:defRPr sz="1200"/>
-            </a:lvl1pPr>
-          </a:lstStyle>
-          <a:p>
-            <a:fld id="{0F89C1C7-3DCD-1040-A9CF-14679D8B5DDD}" type="datetimeFigureOut">
-              <a:rPr lang="en-US" smtClean="0"/>
-              <a:t>10/17/16</a:t>
-            </a:fld>
-            <a:endParaRPr lang="en-US"/>
-          </a:p>
-        </p:txBody>
-      </p:sp>
-      <p:sp>
-        <p:nvSpPr>
-          <p:cNvPr id="4" name="Slide Image Placeholder 3"/>
-          <p:cNvSpPr>
-            <a:spLocks noGrp="1" noRot="1" noChangeAspect="1"/>
-          </p:cNvSpPr>
-          <p:nvPr>
-            <p:ph type="sldImg" idx="2"/>
-          </p:nvPr>
-        </p:nvSpPr>
-        <p:spPr>
-          <a:xfrm>
-            <a:off x="1143000" y="685800"/>
-            <a:ext cx="4572000" cy="3429000"/>
-          </a:xfrm>
-          <a:prstGeom prst="rect">
-            <a:avLst/>
-          </a:prstGeom>
-          <a:noFill/>
-          <a:ln w="12700">
-            <a:solidFill>
-              <a:prstClr val="black"/>
-            </a:solidFill>
-          </a:ln>
-        </p:spPr>
-        <p:txBody>
-          <a:bodyPr vert="horz" lIns="91440" tIns="45720" rIns="91440" bIns="45720" rtlCol="0" anchor="ctr"/>
-          <a:lstStyle/>
-          <a:p>
-            <a:endParaRPr lang="en-US"/>
-          </a:p>
-        </p:txBody>
-      </p:sp>
-      <p:sp>
-        <p:nvSpPr>
-          <p:cNvPr id="5" name="Notes Placeholder 4"/>
-          <p:cNvSpPr>
-            <a:spLocks noGrp="1"/>
-          </p:cNvSpPr>
-          <p:nvPr>
-            <p:ph type="body" sz="quarter" idx="3"/>
-          </p:nvPr>
-        </p:nvSpPr>
-        <p:spPr>
-          <a:xfrm>
-            <a:off x="685800" y="4343400"/>
-            <a:ext cx="5486400" cy="4114800"/>
-          </a:xfrm>
-          <a:prstGeom prst="rect">
-            <a:avLst/>
-          </a:prstGeom>
-        </p:spPr>
-        <p:txBody>
-          <a:bodyPr vert="horz" lIns="91440" tIns="45720" rIns="91440" bIns="45720" rtlCol="0"/>
-          <a:lstStyle/>
-          <a:p>
-            <a:pPr lvl="0"/>
-            <a:r>
-              <a:rPr lang="en-US" smtClean="0"/>
-              <a:t>Click to edit Master text styles</a:t>
-            </a:r>
-          </a:p>
-          <a:p>
-            <a:pPr lvl="1"/>
-            <a:r>
-              <a:rPr lang="en-US" smtClean="0"/>
-              <a:t>Second level</a:t>
-            </a:r>
-          </a:p>
-          <a:p>
-            <a:pPr lvl="2"/>
-            <a:r>
-              <a:rPr lang="en-US" smtClean="0"/>
-              <a:t>Third level</a:t>
-            </a:r>
-          </a:p>
-          <a:p>
-            <a:pPr lvl="3"/>
-            <a:r>
-              <a:rPr lang="en-US" smtClean="0"/>
-              <a:t>Fourth level</a:t>
-            </a:r>
-          </a:p>
-          <a:p>
-            <a:pPr lvl="4"/>
-            <a:r>
-              <a:rPr lang="en-US" smtClean="0"/>
-              <a:t>Fifth level</a:t>
-            </a:r>
-            <a:endParaRPr lang="en-US"/>
-          </a:p>
-        </p:txBody>
-      </p:sp>
-      <p:sp>
-        <p:nvSpPr>
-          <p:cNvPr id="6" name="Footer Placeholder 5"/>
-          <p:cNvSpPr>
-            <a:spLocks noGrp="1"/>
-          </p:cNvSpPr>
-          <p:nvPr>
-            <p:ph type="ftr" sz="quarter" idx="4"/>
-          </p:nvPr>
-        </p:nvSpPr>
-        <p:spPr>
-          <a:xfrm>
-            <a:off x="0" y="8685213"/>
-            <a:ext cx="2971800" cy="457200"/>
-          </a:xfrm>
-          <a:prstGeom prst="rect">
-            <a:avLst/>
-          </a:prstGeom>
-        </p:spPr>
-        <p:txBody>
-          <a:bodyPr vert="horz" lIns="91440" tIns="45720" rIns="91440" bIns="45720" rtlCol="0" anchor="b"/>
-          <a:lstStyle>
-            <a:lvl1pPr algn="l">
-              <a:defRPr sz="1200"/>
-            </a:lvl1pPr>
-          </a:lstStyle>
-          <a:p>
-            <a:endParaRPr lang="en-US"/>
-          </a:p>
-        </p:txBody>
-      </p:sp>
-      <p:sp>
-        <p:nvSpPr>
-          <p:cNvPr id="7" name="Slide Number Placeholder 6"/>
-          <p:cNvSpPr>
-            <a:spLocks noGrp="1"/>
-          </p:cNvSpPr>
-          <p:nvPr>
-            <p:ph type="sldNum" sz="quarter" idx="5"/>
-          </p:nvPr>
-        </p:nvSpPr>
-        <p:spPr>
-          <a:xfrm>
-            <a:off x="3884613" y="8685213"/>
-            <a:ext cx="2971800" cy="457200"/>
-          </a:xfrm>
-          <a:prstGeom prst="rect">
-            <a:avLst/>
-          </a:prstGeom>
-        </p:spPr>
-        <p:txBody>
-          <a:bodyPr vert="horz" lIns="91440" tIns="45720" rIns="91440" bIns="45720" rtlCol="0" anchor="b"/>
-          <a:lstStyle>
-            <a:lvl1pPr algn="r">
-              <a:defRPr sz="1200"/>
-            </a:lvl1pPr>
-          </a:lstStyle>
-          <a:p>
-            <a:fld id="{BB5E49A5-4136-284D-997B-48E1D791AD67}" type="slidenum">
-              <a:rPr lang="en-US" smtClean="0"/>
-              <a:t>‹#›</a:t>
-            </a:fld>
-            <a:endParaRPr lang="en-US"/>
-          </a:p>
-        </p:txBody>
-      </p:sp>
-    </p:spTree>
-    <p:extLst>
-      <p:ext uri="{BB962C8B-B14F-4D97-AF65-F5344CB8AC3E}">
-        <p14:creationId xmlns:p14="http://schemas.microsoft.com/office/powerpoint/2010/main" val="2623252185"/>
-      </p:ext>
-    </p:extLst>
-  </p:cSld>
-  <p:clrMap bg1="lt1" tx1="dk1" bg2="lt2" tx2="dk2" accent1="accent1" accent2="accent2" accent3="accent3" accent4="accent4" accent5="accent5" accent6="accent6" hlink="hlink" folHlink="folHlink"/>
-  <p:notesStyle>
-    <a:lvl1pPr marL="0" algn="l" defTabSz="457200" rtl="0" eaLnBrk="1" latinLnBrk="0" hangingPunct="1">
-      <a:defRPr sz="1200" kern="1200">
-        <a:solidFill>
-          <a:schemeClr val="tx1"/>
-        </a:solidFill>
-        <a:latin typeface="+mn-lt"/>
-        <a:ea typeface="+mn-ea"/>
-        <a:cs typeface="+mn-cs"/>
-      </a:defRPr>
-    </a:lvl1pPr>
-    <a:lvl2pPr marL="457200" algn="l" defTabSz="457200" rtl="0" eaLnBrk="1" latinLnBrk="0" hangingPunct="1">
-      <a:defRPr sz="1200" kern="1200">
-        <a:solidFill>
-          <a:schemeClr val="tx1"/>
-        </a:solidFill>
-        <a:latin typeface="+mn-lt"/>
-        <a:ea typeface="+mn-ea"/>
-        <a:cs typeface="+mn-cs"/>
-      </a:defRPr>
-    </a:lvl2pPr>
-    <a:lvl3pPr marL="914400" algn="l" defTabSz="457200" rtl="0" eaLnBrk="1" latinLnBrk="0" hangingPunct="1">
-      <a:defRPr sz="1200" kern="1200">
-        <a:solidFill>
-          <a:schemeClr val="tx1"/>
-        </a:solidFill>
-        <a:latin typeface="+mn-lt"/>
-        <a:ea typeface="+mn-ea"/>
-        <a:cs typeface="+mn-cs"/>
-      </a:defRPr>
-    </a:lvl3pPr>
-    <a:lvl4pPr marL="1371600" algn="l" defTabSz="457200" rtl="0" eaLnBrk="1" latinLnBrk="0" hangingPunct="1">
-      <a:defRPr sz="1200" kern="1200">
-        <a:solidFill>
-          <a:schemeClr val="tx1"/>
-        </a:solidFill>
-        <a:latin typeface="+mn-lt"/>
-        <a:ea typeface="+mn-ea"/>
-        <a:cs typeface="+mn-cs"/>
-      </a:defRPr>
-    </a:lvl4pPr>
-    <a:lvl5pPr marL="1828800" algn="l" defTabSz="457200" rtl="0" eaLnBrk="1" latinLnBrk="0" hangingPunct="1">
-      <a:defRPr sz="1200" kern="1200">
-        <a:solidFill>
-          <a:schemeClr val="tx1"/>
-        </a:solidFill>
-        <a:latin typeface="+mn-lt"/>
-        <a:ea typeface="+mn-ea"/>
-        <a:cs typeface="+mn-cs"/>
-      </a:defRPr>
-    </a:lvl5pPr>
-    <a:lvl6pPr marL="2286000" algn="l" defTabSz="457200" rtl="0" eaLnBrk="1" latinLnBrk="0" hangingPunct="1">
-      <a:defRPr sz="1200" kern="1200">
-        <a:solidFill>
-          <a:schemeClr val="tx1"/>
-        </a:solidFill>
-        <a:latin typeface="+mn-lt"/>
-        <a:ea typeface="+mn-ea"/>
-        <a:cs typeface="+mn-cs"/>
-      </a:defRPr>
-    </a:lvl6pPr>
-    <a:lvl7pPr marL="2743200" algn="l" defTabSz="457200" rtl="0" eaLnBrk="1" latinLnBrk="0" hangingPunct="1">
-      <a:defRPr sz="1200" kern="1200">
-        <a:solidFill>
-          <a:schemeClr val="tx1"/>
-        </a:solidFill>
-        <a:latin typeface="+mn-lt"/>
-        <a:ea typeface="+mn-ea"/>
-        <a:cs typeface="+mn-cs"/>
-      </a:defRPr>
-    </a:lvl7pPr>
-    <a:lvl8pPr marL="3200400" algn="l" defTabSz="457200" rtl="0" eaLnBrk="1" latinLnBrk="0" hangingPunct="1">
-      <a:defRPr sz="1200" kern="1200">
-        <a:solidFill>
-          <a:schemeClr val="tx1"/>
-        </a:solidFill>
-        <a:latin typeface="+mn-lt"/>
-        <a:ea typeface="+mn-ea"/>
-        <a:cs typeface="+mn-cs"/>
-      </a:defRPr>
-    </a:lvl8pPr>
-    <a:lvl9pPr marL="3657600" algn="l" defTabSz="457200" rtl="0" eaLnBrk="1" latinLnBrk="0" hangingPunct="1">
-      <a:defRPr sz="1200" kern="1200">
-        <a:solidFill>
-          <a:schemeClr val="tx1"/>
-        </a:solidFill>
-        <a:latin typeface="+mn-lt"/>
-        <a:ea typeface="+mn-ea"/>
-        <a:cs typeface="+mn-cs"/>
-      </a:defRPr>
-    </a:lvl9pPr>
-  </p:notesStyle>
-</p:notesMaster>
-</file>
-
-<file path=ppt/notesSlides/notesSlide1.xml><?xml version="1.0" encoding="utf-8"?>
-<p:notes xmlns:a="http://schemas.openxmlformats.org/drawingml/2006/main" xmlns:p="http://schemas.openxmlformats.org/presentationml/2006/main" xmlns:r="http://schemas.openxmlformats.org/officeDocument/2006/relationships">
-  <p:cSld>
-    <p:spTree>
-      <p:nvGrpSpPr>
-        <p:cNvPr id="1" name=""/>
-        <p:cNvGrpSpPr/>
-        <p:nvPr/>
-      </p:nvGrpSpPr>
-      <p:grpSpPr>
-        <a:xfrm>
-          <a:off x="0" y="0"/>
-          <a:ext cx="0" cy="0"/>
-          <a:chOff x="0" y="0"/>
-          <a:chExt cx="0" cy="0"/>
-        </a:xfrm>
-      </p:grpSpPr>
-      <p:sp>
-        <p:nvSpPr>
-          <p:cNvPr id="2" name="Slide Image Placeholder 1"/>
-          <p:cNvSpPr>
-            <a:spLocks noGrp="1"/>
-          </p:cNvSpPr>
-          <p:nvPr>
-            <p:ph type="sldImg" idx="2"/>
-          </p:nvPr>
-        </p:nvSpPr>
-        <p:spPr/>
-      </p:sp>
-      <p:sp>
-        <p:nvSpPr>
-          <p:cNvPr id="3" name="Notes Placeholder 2"/>
-          <p:cNvSpPr>
-            <a:spLocks noGrp="1"/>
-          </p:cNvSpPr>
-          <p:nvPr>
-            <p:ph type="body" idx="3" sz="quarter"/>
-          </p:nvPr>
-        </p:nvSpPr>
-        <p:spPr/>
-        <p:txBody>
-          <a:bodyPr/>
-          <a:lstStyle/>
-          <a:p>
-            <a:r>
-              <a:t>报课程、13组、摸鱼、仓库。不要在封面上念技术细节。</a:t>
-            </a:r>
-          </a:p>
-        </p:txBody>
-      </p:sp>
-      <p:sp>
-        <p:nvSpPr>
-          <p:cNvPr id="4" name="Slide Number Placeholder 3"/>
-          <p:cNvSpPr>
-            <a:spLocks noGrp="1"/>
-          </p:cNvSpPr>
-          <p:nvPr>
-            <p:ph type="sldNum" idx="5" sz="quarter"/>
-          </p:nvPr>
-        </p:nvSpPr>
-        <p:spPr/>
-      </p:sp>
-    </p:spTree>
-  </p:cSld>
-  <p:clrMapOvr>
-    <a:masterClrMapping/>
-  </p:clrMapOvr>
-</p:notes>
-</file>
-
-<file path=ppt/notesSlides/notesSlide10.xml><?xml version="1.0" encoding="utf-8"?>
-<p:notes xmlns:a="http://schemas.openxmlformats.org/drawingml/2006/main" xmlns:p="http://schemas.openxmlformats.org/presentationml/2006/main" xmlns:r="http://schemas.openxmlformats.org/officeDocument/2006/relationships">
-  <p:cSld>
-    <p:spTree>
-      <p:nvGrpSpPr>
-        <p:cNvPr id="1" name=""/>
-        <p:cNvGrpSpPr/>
-        <p:nvPr/>
-      </p:nvGrpSpPr>
-      <p:grpSpPr>
-        <a:xfrm>
-          <a:off x="0" y="0"/>
-          <a:ext cx="0" cy="0"/>
-          <a:chOff x="0" y="0"/>
-          <a:chExt cx="0" cy="0"/>
-        </a:xfrm>
-      </p:grpSpPr>
-      <p:sp>
-        <p:nvSpPr>
-          <p:cNvPr id="2" name="Slide Image Placeholder 1"/>
-          <p:cNvSpPr>
-            <a:spLocks noGrp="1"/>
-          </p:cNvSpPr>
-          <p:nvPr>
-            <p:ph type="sldImg" idx="2"/>
-          </p:nvPr>
-        </p:nvSpPr>
-        <p:spPr/>
-      </p:sp>
-      <p:sp>
-        <p:nvSpPr>
-          <p:cNvPr id="3" name="Notes Placeholder 2"/>
-          <p:cNvSpPr>
-            <a:spLocks noGrp="1"/>
-          </p:cNvSpPr>
-          <p:nvPr>
-            <p:ph type="body" idx="3" sz="quarter"/>
-          </p:nvPr>
-        </p:nvSpPr>
-        <p:spPr/>
-        <p:txBody>
-          <a:bodyPr/>
-          <a:lstStyle/>
-          <a:p>
-            <a:r>
-              <a:t>演示优先打开网页上的 #77。强调测试失败不能发版。</a:t>
-            </a:r>
-          </a:p>
-        </p:txBody>
-      </p:sp>
-      <p:sp>
-        <p:nvSpPr>
-          <p:cNvPr id="4" name="Slide Number Placeholder 3"/>
-          <p:cNvSpPr>
-            <a:spLocks noGrp="1"/>
-          </p:cNvSpPr>
-          <p:nvPr>
-            <p:ph type="sldNum" idx="5" sz="quarter"/>
-          </p:nvPr>
-        </p:nvSpPr>
-        <p:spPr/>
-      </p:sp>
-    </p:spTree>
-  </p:cSld>
-  <p:clrMapOvr>
-    <a:masterClrMapping/>
-  </p:clrMapOvr>
-</p:notes>
-</file>
-
-<file path=ppt/notesSlides/notesSlide11.xml><?xml version="1.0" encoding="utf-8"?>
-<p:notes xmlns:a="http://schemas.openxmlformats.org/drawingml/2006/main" xmlns:p="http://schemas.openxmlformats.org/presentationml/2006/main" xmlns:r="http://schemas.openxmlformats.org/officeDocument/2006/relationships">
-  <p:cSld>
-    <p:spTree>
-      <p:nvGrpSpPr>
-        <p:cNvPr id="1" name=""/>
-        <p:cNvGrpSpPr/>
-        <p:nvPr/>
-      </p:nvGrpSpPr>
-      <p:grpSpPr>
-        <a:xfrm>
-          <a:off x="0" y="0"/>
-          <a:ext cx="0" cy="0"/>
-          <a:chOff x="0" y="0"/>
-          <a:chExt cx="0" cy="0"/>
-        </a:xfrm>
-      </p:grpSpPr>
-      <p:sp>
-        <p:nvSpPr>
-          <p:cNvPr id="2" name="Slide Image Placeholder 1"/>
-          <p:cNvSpPr>
-            <a:spLocks noGrp="1"/>
-          </p:cNvSpPr>
-          <p:nvPr>
-            <p:ph type="sldImg" idx="2"/>
-          </p:nvPr>
-        </p:nvSpPr>
-        <p:spPr/>
-      </p:sp>
-      <p:sp>
-        <p:nvSpPr>
-          <p:cNvPr id="3" name="Notes Placeholder 2"/>
-          <p:cNvSpPr>
-            <a:spLocks noGrp="1"/>
-          </p:cNvSpPr>
-          <p:nvPr>
-            <p:ph type="body" idx="3" sz="quarter"/>
-          </p:nvPr>
-        </p:nvSpPr>
-        <p:spPr/>
-        <p:txBody>
-          <a:bodyPr/>
-          <a:lstStyle/>
-          <a:p>
-            <a:r>
-              <a:t>三个百分比脱口而出，紧接着说「不是架构天然更快」。</a:t>
-            </a:r>
-          </a:p>
-        </p:txBody>
-      </p:sp>
-      <p:sp>
-        <p:nvSpPr>
-          <p:cNvPr id="4" name="Slide Number Placeholder 3"/>
-          <p:cNvSpPr>
-            <a:spLocks noGrp="1"/>
-          </p:cNvSpPr>
-          <p:nvPr>
-            <p:ph type="sldNum" idx="5" sz="quarter"/>
-          </p:nvPr>
-        </p:nvSpPr>
-        <p:spPr/>
-      </p:sp>
-    </p:spTree>
-  </p:cSld>
-  <p:clrMapOvr>
-    <a:masterClrMapping/>
-  </p:clrMapOvr>
-</p:notes>
-</file>
-
-<file path=ppt/notesSlides/notesSlide12.xml><?xml version="1.0" encoding="utf-8"?>
-<p:notes xmlns:a="http://schemas.openxmlformats.org/drawingml/2006/main" xmlns:p="http://schemas.openxmlformats.org/presentationml/2006/main" xmlns:r="http://schemas.openxmlformats.org/officeDocument/2006/relationships">
-  <p:cSld>
-    <p:spTree>
-      <p:nvGrpSpPr>
-        <p:cNvPr id="1" name=""/>
-        <p:cNvGrpSpPr/>
-        <p:nvPr/>
-      </p:nvGrpSpPr>
-      <p:grpSpPr>
-        <a:xfrm>
-          <a:off x="0" y="0"/>
-          <a:ext cx="0" cy="0"/>
-          <a:chOff x="0" y="0"/>
-          <a:chExt cx="0" cy="0"/>
-        </a:xfrm>
-      </p:grpSpPr>
-      <p:sp>
-        <p:nvSpPr>
-          <p:cNvPr id="2" name="Slide Image Placeholder 1"/>
-          <p:cNvSpPr>
-            <a:spLocks noGrp="1"/>
-          </p:cNvSpPr>
-          <p:nvPr>
-            <p:ph type="sldImg" idx="2"/>
-          </p:nvPr>
-        </p:nvSpPr>
-        <p:spPr/>
-      </p:sp>
-      <p:sp>
-        <p:nvSpPr>
-          <p:cNvPr id="3" name="Notes Placeholder 2"/>
-          <p:cNvSpPr>
-            <a:spLocks noGrp="1"/>
-          </p:cNvSpPr>
-          <p:nvPr>
-            <p:ph type="body" idx="3" sz="quarter"/>
-          </p:nvPr>
-        </p:nvSpPr>
-        <p:spPr/>
-        <p:txBody>
-          <a:bodyPr/>
-          <a:lstStyle/>
-          <a:p>
-            <a:r>
-              <a:t>现场放加速录屏。口播 1 到 5 再回到 1。</a:t>
-            </a:r>
-          </a:p>
-        </p:txBody>
-      </p:sp>
-      <p:sp>
-        <p:nvSpPr>
-          <p:cNvPr id="4" name="Slide Number Placeholder 3"/>
-          <p:cNvSpPr>
-            <a:spLocks noGrp="1"/>
-          </p:cNvSpPr>
-          <p:nvPr>
-            <p:ph type="sldNum" idx="5" sz="quarter"/>
-          </p:nvPr>
-        </p:nvSpPr>
-        <p:spPr/>
-      </p:sp>
-    </p:spTree>
-  </p:cSld>
-  <p:clrMapOvr>
-    <a:masterClrMapping/>
-  </p:clrMapOvr>
-</p:notes>
-</file>
-
-<file path=ppt/notesSlides/notesSlide13.xml><?xml version="1.0" encoding="utf-8"?>
-<p:notes xmlns:a="http://schemas.openxmlformats.org/drawingml/2006/main" xmlns:p="http://schemas.openxmlformats.org/presentationml/2006/main" xmlns:r="http://schemas.openxmlformats.org/officeDocument/2006/relationships">
-  <p:cSld>
-    <p:spTree>
-      <p:nvGrpSpPr>
-        <p:cNvPr id="1" name=""/>
-        <p:cNvGrpSpPr/>
-        <p:nvPr/>
-      </p:nvGrpSpPr>
-      <p:grpSpPr>
-        <a:xfrm>
-          <a:off x="0" y="0"/>
-          <a:ext cx="0" cy="0"/>
-          <a:chOff x="0" y="0"/>
-          <a:chExt cx="0" cy="0"/>
-        </a:xfrm>
-      </p:grpSpPr>
-      <p:sp>
-        <p:nvSpPr>
-          <p:cNvPr id="2" name="Slide Image Placeholder 1"/>
-          <p:cNvSpPr>
-            <a:spLocks noGrp="1"/>
-          </p:cNvSpPr>
-          <p:nvPr>
-            <p:ph type="sldImg" idx="2"/>
-          </p:nvPr>
-        </p:nvSpPr>
-        <p:spPr/>
-      </p:sp>
-      <p:sp>
-        <p:nvSpPr>
-          <p:cNvPr id="3" name="Notes Placeholder 2"/>
-          <p:cNvSpPr>
-            <a:spLocks noGrp="1"/>
-          </p:cNvSpPr>
-          <p:nvPr>
-            <p:ph type="body" idx="3" sz="quarter"/>
-          </p:nvPr>
-        </p:nvSpPr>
-        <p:spPr/>
-        <p:txBody>
-          <a:bodyPr/>
-          <a:lstStyle/>
-          <a:p>
-            <a:r>
-              <a:t>强调 503 和 206 是设计出来的，不是偶然报错。</a:t>
-            </a:r>
-          </a:p>
-        </p:txBody>
-      </p:sp>
-      <p:sp>
-        <p:nvSpPr>
-          <p:cNvPr id="4" name="Slide Number Placeholder 3"/>
-          <p:cNvSpPr>
-            <a:spLocks noGrp="1"/>
-          </p:cNvSpPr>
-          <p:nvPr>
-            <p:ph type="sldNum" idx="5" sz="quarter"/>
-          </p:nvPr>
-        </p:nvSpPr>
-        <p:spPr/>
-      </p:sp>
-    </p:spTree>
-  </p:cSld>
-  <p:clrMapOvr>
-    <a:masterClrMapping/>
-  </p:clrMapOvr>
-</p:notes>
-</file>
-
-<file path=ppt/notesSlides/notesSlide14.xml><?xml version="1.0" encoding="utf-8"?>
-<p:notes xmlns:a="http://schemas.openxmlformats.org/drawingml/2006/main" xmlns:p="http://schemas.openxmlformats.org/presentationml/2006/main" xmlns:r="http://schemas.openxmlformats.org/officeDocument/2006/relationships">
-  <p:cSld>
-    <p:spTree>
-      <p:nvGrpSpPr>
-        <p:cNvPr id="1" name=""/>
-        <p:cNvGrpSpPr/>
-        <p:nvPr/>
-      </p:nvGrpSpPr>
-      <p:grpSpPr>
-        <a:xfrm>
-          <a:off x="0" y="0"/>
-          <a:ext cx="0" cy="0"/>
-          <a:chOff x="0" y="0"/>
-          <a:chExt cx="0" cy="0"/>
-        </a:xfrm>
-      </p:grpSpPr>
-      <p:sp>
-        <p:nvSpPr>
-          <p:cNvPr id="2" name="Slide Image Placeholder 1"/>
-          <p:cNvSpPr>
-            <a:spLocks noGrp="1"/>
-          </p:cNvSpPr>
-          <p:nvPr>
-            <p:ph type="sldImg" idx="2"/>
-          </p:nvPr>
-        </p:nvSpPr>
-        <p:spPr/>
-      </p:sp>
-      <p:sp>
-        <p:nvSpPr>
-          <p:cNvPr id="3" name="Notes Placeholder 2"/>
-          <p:cNvSpPr>
-            <a:spLocks noGrp="1"/>
-          </p:cNvSpPr>
-          <p:nvPr>
-            <p:ph type="body" idx="3" sz="quarter"/>
-          </p:nvPr>
-        </p:nvSpPr>
-        <p:spPr/>
-        <p:txBody>
-          <a:bodyPr/>
-          <a:lstStyle/>
-          <a:p>
-            <a:r>
-              <a:t>演示按表走。录屏组员嵌入。</a:t>
-            </a:r>
-          </a:p>
-        </p:txBody>
-      </p:sp>
-      <p:sp>
-        <p:nvSpPr>
-          <p:cNvPr id="4" name="Slide Number Placeholder 3"/>
-          <p:cNvSpPr>
-            <a:spLocks noGrp="1"/>
-          </p:cNvSpPr>
-          <p:nvPr>
-            <p:ph type="sldNum" idx="5" sz="quarter"/>
-          </p:nvPr>
-        </p:nvSpPr>
-        <p:spPr/>
-      </p:sp>
-    </p:spTree>
-  </p:cSld>
-  <p:clrMapOvr>
-    <a:masterClrMapping/>
-  </p:clrMapOvr>
-</p:notes>
-</file>
-
-<file path=ppt/notesSlides/notesSlide15.xml><?xml version="1.0" encoding="utf-8"?>
-<p:notes xmlns:a="http://schemas.openxmlformats.org/drawingml/2006/main" xmlns:p="http://schemas.openxmlformats.org/presentationml/2006/main" xmlns:r="http://schemas.openxmlformats.org/officeDocument/2006/relationships">
-  <p:cSld>
-    <p:spTree>
-      <p:nvGrpSpPr>
-        <p:cNvPr id="1" name=""/>
-        <p:cNvGrpSpPr/>
-        <p:nvPr/>
-      </p:nvGrpSpPr>
-      <p:grpSpPr>
-        <a:xfrm>
-          <a:off x="0" y="0"/>
-          <a:ext cx="0" cy="0"/>
-          <a:chOff x="0" y="0"/>
-          <a:chExt cx="0" cy="0"/>
-        </a:xfrm>
-      </p:grpSpPr>
-      <p:sp>
-        <p:nvSpPr>
-          <p:cNvPr id="2" name="Slide Image Placeholder 1"/>
-          <p:cNvSpPr>
-            <a:spLocks noGrp="1"/>
-          </p:cNvSpPr>
-          <p:nvPr>
-            <p:ph type="sldImg" idx="2"/>
-          </p:nvPr>
-        </p:nvSpPr>
-        <p:spPr/>
-      </p:sp>
-      <p:sp>
-        <p:nvSpPr>
-          <p:cNvPr id="3" name="Notes Placeholder 2"/>
-          <p:cNvSpPr>
-            <a:spLocks noGrp="1"/>
-          </p:cNvSpPr>
-          <p:nvPr>
-            <p:ph type="body" idx="3" sz="quarter"/>
-          </p:nvPr>
-        </p:nvSpPr>
-        <p:spPr/>
-        <p:txBody>
-          <a:bodyPr/>
-          <a:lstStyle/>
-          <a:p>
-            <a:r>
-              <a:t>权重说待确认。AI 说辅助+人工真跑。</a:t>
-            </a:r>
-          </a:p>
-        </p:txBody>
-      </p:sp>
-      <p:sp>
-        <p:nvSpPr>
-          <p:cNvPr id="4" name="Slide Number Placeholder 3"/>
-          <p:cNvSpPr>
-            <a:spLocks noGrp="1"/>
-          </p:cNvSpPr>
-          <p:nvPr>
-            <p:ph type="sldNum" idx="5" sz="quarter"/>
-          </p:nvPr>
-        </p:nvSpPr>
-        <p:spPr/>
-      </p:sp>
-    </p:spTree>
-  </p:cSld>
-  <p:clrMapOvr>
-    <a:masterClrMapping/>
-  </p:clrMapOvr>
-</p:notes>
-</file>
-
-<file path=ppt/notesSlides/notesSlide16.xml><?xml version="1.0" encoding="utf-8"?>
-<p:notes xmlns:a="http://schemas.openxmlformats.org/drawingml/2006/main" xmlns:p="http://schemas.openxmlformats.org/presentationml/2006/main" xmlns:r="http://schemas.openxmlformats.org/officeDocument/2006/relationships">
-  <p:cSld>
-    <p:spTree>
-      <p:nvGrpSpPr>
-        <p:cNvPr id="1" name=""/>
-        <p:cNvGrpSpPr/>
-        <p:nvPr/>
-      </p:nvGrpSpPr>
-      <p:grpSpPr>
-        <a:xfrm>
-          <a:off x="0" y="0"/>
-          <a:ext cx="0" cy="0"/>
-          <a:chOff x="0" y="0"/>
-          <a:chExt cx="0" cy="0"/>
-        </a:xfrm>
-      </p:grpSpPr>
-      <p:sp>
-        <p:nvSpPr>
-          <p:cNvPr id="2" name="Slide Image Placeholder 1"/>
-          <p:cNvSpPr>
-            <a:spLocks noGrp="1"/>
-          </p:cNvSpPr>
-          <p:nvPr>
-            <p:ph type="sldImg" idx="2"/>
-          </p:nvPr>
-        </p:nvSpPr>
-        <p:spPr/>
-      </p:sp>
-      <p:sp>
-        <p:nvSpPr>
-          <p:cNvPr id="3" name="Notes Placeholder 2"/>
-          <p:cNvSpPr>
-            <a:spLocks noGrp="1"/>
-          </p:cNvSpPr>
-          <p:nvPr>
-            <p:ph type="body" idx="3" sz="quarter"/>
-          </p:nvPr>
-        </p:nvSpPr>
-        <p:spPr/>
-        <p:txBody>
-          <a:bodyPr/>
-          <a:lstStyle/>
-          <a:p>
-            <a:r>
-              <a:t>限制主动交代一句即可。</a:t>
-            </a:r>
-          </a:p>
-        </p:txBody>
-      </p:sp>
-      <p:sp>
-        <p:nvSpPr>
-          <p:cNvPr id="4" name="Slide Number Placeholder 3"/>
-          <p:cNvSpPr>
-            <a:spLocks noGrp="1"/>
-          </p:cNvSpPr>
-          <p:nvPr>
-            <p:ph type="sldNum" idx="5" sz="quarter"/>
-          </p:nvPr>
-        </p:nvSpPr>
-        <p:spPr/>
-      </p:sp>
-    </p:spTree>
-  </p:cSld>
-  <p:clrMapOvr>
-    <a:masterClrMapping/>
-  </p:clrMapOvr>
-</p:notes>
-</file>
-
-<file path=ppt/notesSlides/notesSlide17.xml><?xml version="1.0" encoding="utf-8"?>
-<p:notes xmlns:a="http://schemas.openxmlformats.org/drawingml/2006/main" xmlns:p="http://schemas.openxmlformats.org/presentationml/2006/main" xmlns:r="http://schemas.openxmlformats.org/officeDocument/2006/relationships">
-  <p:cSld>
-    <p:spTree>
-      <p:nvGrpSpPr>
-        <p:cNvPr id="1" name=""/>
-        <p:cNvGrpSpPr/>
-        <p:nvPr/>
-      </p:nvGrpSpPr>
-      <p:grpSpPr>
-        <a:xfrm>
-          <a:off x="0" y="0"/>
-          <a:ext cx="0" cy="0"/>
-          <a:chOff x="0" y="0"/>
-          <a:chExt cx="0" cy="0"/>
-        </a:xfrm>
-      </p:grpSpPr>
-      <p:sp>
-        <p:nvSpPr>
-          <p:cNvPr id="2" name="Slide Image Placeholder 1"/>
-          <p:cNvSpPr>
-            <a:spLocks noGrp="1"/>
-          </p:cNvSpPr>
-          <p:nvPr>
-            <p:ph type="sldImg" idx="2"/>
-          </p:nvPr>
-        </p:nvSpPr>
-        <p:spPr/>
-      </p:sp>
-      <p:sp>
-        <p:nvSpPr>
-          <p:cNvPr id="3" name="Notes Placeholder 2"/>
-          <p:cNvSpPr>
-            <a:spLocks noGrp="1"/>
-          </p:cNvSpPr>
-          <p:nvPr>
-            <p:ph type="body" idx="3" sz="quarter"/>
-          </p:nvPr>
-        </p:nvSpPr>
-        <p:spPr/>
-        <p:txBody>
-          <a:bodyPr/>
-          <a:lstStyle/>
-          <a:p>
-            <a:r>
-              <a:t>老师原话优先。补充四问各一句。</a:t>
-            </a:r>
-          </a:p>
-        </p:txBody>
-      </p:sp>
-      <p:sp>
-        <p:nvSpPr>
-          <p:cNvPr id="4" name="Slide Number Placeholder 3"/>
-          <p:cNvSpPr>
-            <a:spLocks noGrp="1"/>
-          </p:cNvSpPr>
-          <p:nvPr>
-            <p:ph type="sldNum" idx="5" sz="quarter"/>
-          </p:nvPr>
-        </p:nvSpPr>
-        <p:spPr/>
-      </p:sp>
-    </p:spTree>
-  </p:cSld>
-  <p:clrMapOvr>
-    <a:masterClrMapping/>
-  </p:clrMapOvr>
-</p:notes>
-</file>
-
-<file path=ppt/notesSlides/notesSlide18.xml><?xml version="1.0" encoding="utf-8"?>
-<p:notes xmlns:a="http://schemas.openxmlformats.org/drawingml/2006/main" xmlns:p="http://schemas.openxmlformats.org/presentationml/2006/main" xmlns:r="http://schemas.openxmlformats.org/officeDocument/2006/relationships">
-  <p:cSld>
-    <p:spTree>
-      <p:nvGrpSpPr>
-        <p:cNvPr id="1" name=""/>
-        <p:cNvGrpSpPr/>
-        <p:nvPr/>
-      </p:nvGrpSpPr>
-      <p:grpSpPr>
-        <a:xfrm>
-          <a:off x="0" y="0"/>
-          <a:ext cx="0" cy="0"/>
-          <a:chOff x="0" y="0"/>
-          <a:chExt cx="0" cy="0"/>
-        </a:xfrm>
-      </p:grpSpPr>
-      <p:sp>
-        <p:nvSpPr>
-          <p:cNvPr id="2" name="Slide Image Placeholder 1"/>
-          <p:cNvSpPr>
-            <a:spLocks noGrp="1"/>
-          </p:cNvSpPr>
-          <p:nvPr>
-            <p:ph type="sldImg" idx="2"/>
-          </p:nvPr>
-        </p:nvSpPr>
-        <p:spPr/>
-      </p:sp>
-      <p:sp>
-        <p:nvSpPr>
-          <p:cNvPr id="3" name="Notes Placeholder 2"/>
-          <p:cNvSpPr>
-            <a:spLocks noGrp="1"/>
-          </p:cNvSpPr>
-          <p:nvPr>
-            <p:ph type="body" idx="3" sz="quarter"/>
-          </p:nvPr>
-        </p:nvSpPr>
-        <p:spPr/>
-        <p:txBody>
-          <a:bodyPr/>
-          <a:lstStyle/>
-          <a:p>
-            <a:r>
-              <a:t>停住等提问。</a:t>
-            </a:r>
-          </a:p>
-        </p:txBody>
-      </p:sp>
-      <p:sp>
-        <p:nvSpPr>
-          <p:cNvPr id="4" name="Slide Number Placeholder 3"/>
-          <p:cNvSpPr>
-            <a:spLocks noGrp="1"/>
-          </p:cNvSpPr>
-          <p:nvPr>
-            <p:ph type="sldNum" idx="5" sz="quarter"/>
-          </p:nvPr>
-        </p:nvSpPr>
-        <p:spPr/>
-      </p:sp>
-    </p:spTree>
-  </p:cSld>
-  <p:clrMapOvr>
-    <a:masterClrMapping/>
-  </p:clrMapOvr>
-</p:notes>
-</file>
-
-<file path=ppt/notesSlides/notesSlide2.xml><?xml version="1.0" encoding="utf-8"?>
-<p:notes xmlns:a="http://schemas.openxmlformats.org/drawingml/2006/main" xmlns:p="http://schemas.openxmlformats.org/presentationml/2006/main" xmlns:r="http://schemas.openxmlformats.org/officeDocument/2006/relationships">
-  <p:cSld>
-    <p:spTree>
-      <p:nvGrpSpPr>
-        <p:cNvPr id="1" name=""/>
-        <p:cNvGrpSpPr/>
-        <p:nvPr/>
-      </p:nvGrpSpPr>
-      <p:grpSpPr>
-        <a:xfrm>
-          <a:off x="0" y="0"/>
-          <a:ext cx="0" cy="0"/>
-          <a:chOff x="0" y="0"/>
-          <a:chExt cx="0" cy="0"/>
-        </a:xfrm>
-      </p:grpSpPr>
-      <p:sp>
-        <p:nvSpPr>
-          <p:cNvPr id="2" name="Slide Image Placeholder 1"/>
-          <p:cNvSpPr>
-            <a:spLocks noGrp="1"/>
-          </p:cNvSpPr>
-          <p:nvPr>
-            <p:ph type="sldImg" idx="2"/>
-          </p:nvPr>
-        </p:nvSpPr>
-        <p:spPr/>
-      </p:sp>
-      <p:sp>
-        <p:nvSpPr>
-          <p:cNvPr id="3" name="Notes Placeholder 2"/>
-          <p:cNvSpPr>
-            <a:spLocks noGrp="1"/>
-          </p:cNvSpPr>
-          <p:nvPr>
-            <p:ph type="body" idx="3" sz="quarter"/>
-          </p:nvPr>
-        </p:nvSpPr>
-        <p:spPr/>
-        <p:txBody>
-          <a:bodyPr/>
-          <a:lstStyle/>
-          <a:p>
-            <a:r>
-              <a:t>先把 3+4+3 报清楚，再进入项目。</a:t>
-            </a:r>
-          </a:p>
-        </p:txBody>
-      </p:sp>
-      <p:sp>
-        <p:nvSpPr>
-          <p:cNvPr id="4" name="Slide Number Placeholder 3"/>
-          <p:cNvSpPr>
-            <a:spLocks noGrp="1"/>
-          </p:cNvSpPr>
-          <p:nvPr>
-            <p:ph type="sldNum" idx="5" sz="quarter"/>
-          </p:nvPr>
-        </p:nvSpPr>
-        <p:spPr/>
-      </p:sp>
-    </p:spTree>
-  </p:cSld>
-  <p:clrMapOvr>
-    <a:masterClrMapping/>
-  </p:clrMapOvr>
-</p:notes>
-</file>
-
-<file path=ppt/notesSlides/notesSlide3.xml><?xml version="1.0" encoding="utf-8"?>
-<p:notes xmlns:a="http://schemas.openxmlformats.org/drawingml/2006/main" xmlns:p="http://schemas.openxmlformats.org/presentationml/2006/main" xmlns:r="http://schemas.openxmlformats.org/officeDocument/2006/relationships">
-  <p:cSld>
-    <p:spTree>
-      <p:nvGrpSpPr>
-        <p:cNvPr id="1" name=""/>
-        <p:cNvGrpSpPr/>
-        <p:nvPr/>
-      </p:nvGrpSpPr>
-      <p:grpSpPr>
-        <a:xfrm>
-          <a:off x="0" y="0"/>
-          <a:ext cx="0" cy="0"/>
-          <a:chOff x="0" y="0"/>
-          <a:chExt cx="0" cy="0"/>
-        </a:xfrm>
-      </p:grpSpPr>
-      <p:sp>
-        <p:nvSpPr>
-          <p:cNvPr id="2" name="Slide Image Placeholder 1"/>
-          <p:cNvSpPr>
-            <a:spLocks noGrp="1"/>
-          </p:cNvSpPr>
-          <p:nvPr>
-            <p:ph type="sldImg" idx="2"/>
-          </p:nvPr>
-        </p:nvSpPr>
-        <p:spPr/>
-      </p:sp>
-      <p:sp>
-        <p:nvSpPr>
-          <p:cNvPr id="3" name="Notes Placeholder 2"/>
-          <p:cNvSpPr>
-            <a:spLocks noGrp="1"/>
-          </p:cNvSpPr>
-          <p:nvPr>
-            <p:ph type="body" idx="3" sz="quarter"/>
-          </p:nvPr>
-        </p:nvSpPr>
-        <p:spPr/>
-        <p:txBody>
-          <a:bodyPr/>
-          <a:lstStyle/>
-          <a:p>
-            <a:r>
-              <a:t>原系统一个后端一个库；小学期加上容器、流水线、K8s 和三服务。</a:t>
-            </a:r>
-          </a:p>
-        </p:txBody>
-      </p:sp>
-      <p:sp>
-        <p:nvSpPr>
-          <p:cNvPr id="4" name="Slide Number Placeholder 3"/>
-          <p:cNvSpPr>
-            <a:spLocks noGrp="1"/>
-          </p:cNvSpPr>
-          <p:nvPr>
-            <p:ph type="sldNum" idx="5" sz="quarter"/>
-          </p:nvPr>
-        </p:nvSpPr>
-        <p:spPr/>
-      </p:sp>
-    </p:spTree>
-  </p:cSld>
-  <p:clrMapOvr>
-    <a:masterClrMapping/>
-  </p:clrMapOvr>
-</p:notes>
-</file>
-
-<file path=ppt/notesSlides/notesSlide4.xml><?xml version="1.0" encoding="utf-8"?>
-<p:notes xmlns:a="http://schemas.openxmlformats.org/drawingml/2006/main" xmlns:p="http://schemas.openxmlformats.org/presentationml/2006/main" xmlns:r="http://schemas.openxmlformats.org/officeDocument/2006/relationships">
-  <p:cSld>
-    <p:spTree>
-      <p:nvGrpSpPr>
-        <p:cNvPr id="1" name=""/>
-        <p:cNvGrpSpPr/>
-        <p:nvPr/>
-      </p:nvGrpSpPr>
-      <p:grpSpPr>
-        <a:xfrm>
-          <a:off x="0" y="0"/>
-          <a:ext cx="0" cy="0"/>
-          <a:chOff x="0" y="0"/>
-          <a:chExt cx="0" cy="0"/>
-        </a:xfrm>
-      </p:grpSpPr>
-      <p:sp>
-        <p:nvSpPr>
-          <p:cNvPr id="2" name="Slide Image Placeholder 1"/>
-          <p:cNvSpPr>
-            <a:spLocks noGrp="1"/>
-          </p:cNvSpPr>
-          <p:nvPr>
-            <p:ph type="sldImg" idx="2"/>
-          </p:nvPr>
-        </p:nvSpPr>
-        <p:spPr/>
-      </p:sp>
-      <p:sp>
-        <p:nvSpPr>
-          <p:cNvPr id="3" name="Notes Placeholder 2"/>
-          <p:cNvSpPr>
-            <a:spLocks noGrp="1"/>
-          </p:cNvSpPr>
-          <p:nvPr>
-            <p:ph type="body" idx="3" sz="quarter"/>
-          </p:nvPr>
-        </p:nvSpPr>
-        <p:spPr/>
-        <p:txBody>
-          <a:bodyPr/>
-          <a:lstStyle/>
-          <a:p>
-            <a:r>
-              <a:t>12 个都做完。今天现场只走 UC01、UC02、UC04。</a:t>
-            </a:r>
-          </a:p>
-        </p:txBody>
-      </p:sp>
-      <p:sp>
-        <p:nvSpPr>
-          <p:cNvPr id="4" name="Slide Number Placeholder 3"/>
-          <p:cNvSpPr>
-            <a:spLocks noGrp="1"/>
-          </p:cNvSpPr>
-          <p:nvPr>
-            <p:ph type="sldNum" idx="5" sz="quarter"/>
-          </p:nvPr>
-        </p:nvSpPr>
-        <p:spPr/>
-      </p:sp>
-    </p:spTree>
-  </p:cSld>
-  <p:clrMapOvr>
-    <a:masterClrMapping/>
-  </p:clrMapOvr>
-</p:notes>
-</file>
-
-<file path=ppt/notesSlides/notesSlide5.xml><?xml version="1.0" encoding="utf-8"?>
-<p:notes xmlns:a="http://schemas.openxmlformats.org/drawingml/2006/main" xmlns:p="http://schemas.openxmlformats.org/presentationml/2006/main" xmlns:r="http://schemas.openxmlformats.org/officeDocument/2006/relationships">
-  <p:cSld>
-    <p:spTree>
-      <p:nvGrpSpPr>
-        <p:cNvPr id="1" name=""/>
-        <p:cNvGrpSpPr/>
-        <p:nvPr/>
-      </p:nvGrpSpPr>
-      <p:grpSpPr>
-        <a:xfrm>
-          <a:off x="0" y="0"/>
-          <a:ext cx="0" cy="0"/>
-          <a:chOff x="0" y="0"/>
-          <a:chExt cx="0" cy="0"/>
-        </a:xfrm>
-      </p:grpSpPr>
-      <p:sp>
-        <p:nvSpPr>
-          <p:cNvPr id="2" name="Slide Image Placeholder 1"/>
-          <p:cNvSpPr>
-            <a:spLocks noGrp="1"/>
-          </p:cNvSpPr>
-          <p:nvPr>
-            <p:ph type="sldImg" idx="2"/>
-          </p:nvPr>
-        </p:nvSpPr>
-        <p:spPr/>
-      </p:sp>
-      <p:sp>
-        <p:nvSpPr>
-          <p:cNvPr id="3" name="Notes Placeholder 2"/>
-          <p:cNvSpPr>
-            <a:spLocks noGrp="1"/>
-          </p:cNvSpPr>
-          <p:nvPr>
-            <p:ph type="body" idx="3" sz="quarter"/>
-          </p:nvPr>
-        </p:nvSpPr>
-        <p:spPr/>
-        <p:txBody>
-          <a:bodyPr/>
-          <a:lstStyle/>
-          <a:p>
-            <a:r>
-              <a:t>点 UC04：需求图画人怎么走，代码在 orderController，测试编号能对上。</a:t>
-            </a:r>
-          </a:p>
-        </p:txBody>
-      </p:sp>
-      <p:sp>
-        <p:nvSpPr>
-          <p:cNvPr id="4" name="Slide Number Placeholder 3"/>
-          <p:cNvSpPr>
-            <a:spLocks noGrp="1"/>
-          </p:cNvSpPr>
-          <p:nvPr>
-            <p:ph type="sldNum" idx="5" sz="quarter"/>
-          </p:nvPr>
-        </p:nvSpPr>
-        <p:spPr/>
-      </p:sp>
-    </p:spTree>
-  </p:cSld>
-  <p:clrMapOvr>
-    <a:masterClrMapping/>
-  </p:clrMapOvr>
-</p:notes>
-</file>
-
-<file path=ppt/notesSlides/notesSlide6.xml><?xml version="1.0" encoding="utf-8"?>
-<p:notes xmlns:a="http://schemas.openxmlformats.org/drawingml/2006/main" xmlns:p="http://schemas.openxmlformats.org/presentationml/2006/main" xmlns:r="http://schemas.openxmlformats.org/officeDocument/2006/relationships">
-  <p:cSld>
-    <p:spTree>
-      <p:nvGrpSpPr>
-        <p:cNvPr id="1" name=""/>
-        <p:cNvGrpSpPr/>
-        <p:nvPr/>
-      </p:nvGrpSpPr>
-      <p:grpSpPr>
-        <a:xfrm>
-          <a:off x="0" y="0"/>
-          <a:ext cx="0" cy="0"/>
-          <a:chOff x="0" y="0"/>
-          <a:chExt cx="0" cy="0"/>
-        </a:xfrm>
-      </p:grpSpPr>
-      <p:sp>
-        <p:nvSpPr>
-          <p:cNvPr id="2" name="Slide Image Placeholder 1"/>
-          <p:cNvSpPr>
-            <a:spLocks noGrp="1"/>
-          </p:cNvSpPr>
-          <p:nvPr>
-            <p:ph type="sldImg" idx="2"/>
-          </p:nvPr>
-        </p:nvSpPr>
-        <p:spPr/>
-      </p:sp>
-      <p:sp>
-        <p:nvSpPr>
-          <p:cNvPr id="3" name="Notes Placeholder 2"/>
-          <p:cNvSpPr>
-            <a:spLocks noGrp="1"/>
-          </p:cNvSpPr>
-          <p:nvPr>
-            <p:ph type="body" idx="3" sz="quarter"/>
-          </p:nvPr>
-        </p:nvSpPr>
-        <p:spPr/>
-        <p:txBody>
-          <a:bodyPr/>
-          <a:lstStyle/>
-          <a:p>
-            <a:r>
-              <a:t>不要在这页念每一条箭头，指状态机和 createOrder 即可。</a:t>
-            </a:r>
-          </a:p>
-        </p:txBody>
-      </p:sp>
-      <p:sp>
-        <p:nvSpPr>
-          <p:cNvPr id="4" name="Slide Number Placeholder 3"/>
-          <p:cNvSpPr>
-            <a:spLocks noGrp="1"/>
-          </p:cNvSpPr>
-          <p:nvPr>
-            <p:ph type="sldNum" idx="5" sz="quarter"/>
-          </p:nvPr>
-        </p:nvSpPr>
-        <p:spPr/>
-      </p:sp>
-    </p:spTree>
-  </p:cSld>
-  <p:clrMapOvr>
-    <a:masterClrMapping/>
-  </p:clrMapOvr>
-</p:notes>
-</file>
-
-<file path=ppt/notesSlides/notesSlide7.xml><?xml version="1.0" encoding="utf-8"?>
-<p:notes xmlns:a="http://schemas.openxmlformats.org/drawingml/2006/main" xmlns:p="http://schemas.openxmlformats.org/presentationml/2006/main" xmlns:r="http://schemas.openxmlformats.org/officeDocument/2006/relationships">
-  <p:cSld>
-    <p:spTree>
-      <p:nvGrpSpPr>
-        <p:cNvPr id="1" name=""/>
-        <p:cNvGrpSpPr/>
-        <p:nvPr/>
-      </p:nvGrpSpPr>
-      <p:grpSpPr>
-        <a:xfrm>
-          <a:off x="0" y="0"/>
-          <a:ext cx="0" cy="0"/>
-          <a:chOff x="0" y="0"/>
-          <a:chExt cx="0" cy="0"/>
-        </a:xfrm>
-      </p:grpSpPr>
-      <p:sp>
-        <p:nvSpPr>
-          <p:cNvPr id="2" name="Slide Image Placeholder 1"/>
-          <p:cNvSpPr>
-            <a:spLocks noGrp="1"/>
-          </p:cNvSpPr>
-          <p:nvPr>
-            <p:ph type="sldImg" idx="2"/>
-          </p:nvPr>
-        </p:nvSpPr>
-        <p:spPr/>
-      </p:sp>
-      <p:sp>
-        <p:nvSpPr>
-          <p:cNvPr id="3" name="Notes Placeholder 2"/>
-          <p:cNvSpPr>
-            <a:spLocks noGrp="1"/>
-          </p:cNvSpPr>
-          <p:nvPr>
-            <p:ph type="body" idx="3" sz="quarter"/>
-          </p:nvPr>
-        </p:nvSpPr>
-        <p:spPr/>
-        <p:txBody>
-          <a:bodyPr/>
-          <a:lstStyle/>
-          <a:p>
-            <a:r>
-              <a:t>身份、标的、交易过程。网关不算第四个业务服务。</a:t>
-            </a:r>
-          </a:p>
-        </p:txBody>
-      </p:sp>
-      <p:sp>
-        <p:nvSpPr>
-          <p:cNvPr id="4" name="Slide Number Placeholder 3"/>
-          <p:cNvSpPr>
-            <a:spLocks noGrp="1"/>
-          </p:cNvSpPr>
-          <p:nvPr>
-            <p:ph type="sldNum" idx="5" sz="quarter"/>
-          </p:nvPr>
-        </p:nvSpPr>
-        <p:spPr/>
-      </p:sp>
-    </p:spTree>
-  </p:cSld>
-  <p:clrMapOvr>
-    <a:masterClrMapping/>
-  </p:clrMapOvr>
-</p:notes>
-</file>
-
-<file path=ppt/notesSlides/notesSlide8.xml><?xml version="1.0" encoding="utf-8"?>
-<p:notes xmlns:a="http://schemas.openxmlformats.org/drawingml/2006/main" xmlns:p="http://schemas.openxmlformats.org/presentationml/2006/main" xmlns:r="http://schemas.openxmlformats.org/officeDocument/2006/relationships">
-  <p:cSld>
-    <p:spTree>
-      <p:nvGrpSpPr>
-        <p:cNvPr id="1" name=""/>
-        <p:cNvGrpSpPr/>
-        <p:nvPr/>
-      </p:nvGrpSpPr>
-      <p:grpSpPr>
-        <a:xfrm>
-          <a:off x="0" y="0"/>
-          <a:ext cx="0" cy="0"/>
-          <a:chOff x="0" y="0"/>
-          <a:chExt cx="0" cy="0"/>
-        </a:xfrm>
-      </p:grpSpPr>
-      <p:sp>
-        <p:nvSpPr>
-          <p:cNvPr id="2" name="Slide Image Placeholder 1"/>
-          <p:cNvSpPr>
-            <a:spLocks noGrp="1"/>
-          </p:cNvSpPr>
-          <p:nvPr>
-            <p:ph type="sldImg" idx="2"/>
-          </p:nvPr>
-        </p:nvSpPr>
-        <p:spPr/>
-      </p:sp>
-      <p:sp>
-        <p:nvSpPr>
-          <p:cNvPr id="3" name="Notes Placeholder 2"/>
-          <p:cNvSpPr>
-            <a:spLocks noGrp="1"/>
-          </p:cNvSpPr>
-          <p:nvPr>
-            <p:ph type="body" idx="3" sz="quarter"/>
-          </p:nvPr>
-        </p:nvSpPr>
-        <p:spPr/>
-        <p:txBody>
-          <a:bodyPr/>
-          <a:lstStyle/>
-          <a:p>
-            <a:r>
-              <a:t>失败处理抓 503 和 206 两张牌。内部接口有 token。</a:t>
-            </a:r>
-          </a:p>
-        </p:txBody>
-      </p:sp>
-      <p:sp>
-        <p:nvSpPr>
-          <p:cNvPr id="4" name="Slide Number Placeholder 3"/>
-          <p:cNvSpPr>
-            <a:spLocks noGrp="1"/>
-          </p:cNvSpPr>
-          <p:nvPr>
-            <p:ph type="sldNum" idx="5" sz="quarter"/>
-          </p:nvPr>
-        </p:nvSpPr>
-        <p:spPr/>
-      </p:sp>
-    </p:spTree>
-  </p:cSld>
-  <p:clrMapOvr>
-    <a:masterClrMapping/>
-  </p:clrMapOvr>
-</p:notes>
-</file>
-
-<file path=ppt/notesSlides/notesSlide9.xml><?xml version="1.0" encoding="utf-8"?>
-<p:notes xmlns:a="http://schemas.openxmlformats.org/drawingml/2006/main" xmlns:p="http://schemas.openxmlformats.org/presentationml/2006/main" xmlns:r="http://schemas.openxmlformats.org/officeDocument/2006/relationships">
-  <p:cSld>
-    <p:spTree>
-      <p:nvGrpSpPr>
-        <p:cNvPr id="1" name=""/>
-        <p:cNvGrpSpPr/>
-        <p:nvPr/>
-      </p:nvGrpSpPr>
-      <p:grpSpPr>
-        <a:xfrm>
-          <a:off x="0" y="0"/>
-          <a:ext cx="0" cy="0"/>
-          <a:chOff x="0" y="0"/>
-          <a:chExt cx="0" cy="0"/>
-        </a:xfrm>
-      </p:grpSpPr>
-      <p:sp>
-        <p:nvSpPr>
-          <p:cNvPr id="2" name="Slide Image Placeholder 1"/>
-          <p:cNvSpPr>
-            <a:spLocks noGrp="1"/>
-          </p:cNvSpPr>
-          <p:nvPr>
-            <p:ph type="sldImg" idx="2"/>
-          </p:nvPr>
-        </p:nvSpPr>
-        <p:spPr/>
-      </p:sp>
-      <p:sp>
-        <p:nvSpPr>
-          <p:cNvPr id="3" name="Notes Placeholder 2"/>
-          <p:cNvSpPr>
-            <a:spLocks noGrp="1"/>
-          </p:cNvSpPr>
-          <p:nvPr>
-            <p:ph type="body" idx="3" sz="quarter"/>
-          </p:nvPr>
-        </p:nvSpPr>
-        <p:spPr/>
-        <p:txBody>
-          <a:bodyPr/>
-          <a:lstStyle/>
-          <a:p>
-            <a:r>
-              <a:t>报几个大数：220、42/42、32/32。前端新增 100 要诚实说待复跑。</a:t>
-            </a:r>
-          </a:p>
-        </p:txBody>
-      </p:sp>
-      <p:sp>
-        <p:nvSpPr>
-          <p:cNvPr id="4" name="Slide Number Placeholder 3"/>
-          <p:cNvSpPr>
-            <a:spLocks noGrp="1"/>
-          </p:cNvSpPr>
-          <p:nvPr>
-            <p:ph type="sldNum" idx="5" sz="quarter"/>
-          </p:nvPr>
-        </p:nvSpPr>
-        <p:spPr/>
-      </p:sp>
-    </p:spTree>
-  </p:cSld>
-  <p:clrMapOvr>
-    <a:masterClrMapping/>
-  </p:clrMapOvr>
-</p:notes>
 </file>
 
 <file path=ppt/slideLayouts/slideLayout1.xml><?xml version="1.0" encoding="utf-8"?>
@@ -4715,408 +3094,79 @@
         <p:nvPr/>
       </p:nvGrpSpPr>
       <p:grpSpPr/>
-      <p:pic>
-        <p:nvPicPr>
-          <p:cNvPr id="2" name="Picture 1" descr="S01.png"/>
-          <p:cNvPicPr>
-            <a:picLocks noChangeAspect="1"/>
-          </p:cNvPicPr>
-          <p:nvPr/>
-        </p:nvPicPr>
-        <p:blipFill>
-          <a:blip r:embed="rId2"/>
-          <a:stretch>
-            <a:fillRect/>
-          </a:stretch>
-        </p:blipFill>
-        <p:spPr>
-          <a:xfrm>
-            <a:off x="0" y="0"/>
-            <a:ext cx="12191999" cy="6858000"/>
-          </a:xfrm>
-          <a:prstGeom prst="rect">
-            <a:avLst/>
-          </a:prstGeom>
-        </p:spPr>
-      </p:pic>
-    </p:spTree>
-  </p:cSld>
-  <p:clrMapOvr>
-    <a:masterClrMapping/>
-  </p:clrMapOvr>
-</p:sld>
-</file>
-
-<file path=ppt/slides/slide10.xml><?xml version="1.0" encoding="utf-8"?>
-<p:sld xmlns:a="http://schemas.openxmlformats.org/drawingml/2006/main" xmlns:p="http://schemas.openxmlformats.org/presentationml/2006/main" xmlns:r="http://schemas.openxmlformats.org/officeDocument/2006/relationships">
-  <p:cSld>
-    <p:spTree>
-      <p:nvGrpSpPr>
-        <p:cNvPr id="1" name=""/>
-        <p:cNvGrpSpPr/>
-        <p:nvPr/>
-      </p:nvGrpSpPr>
-      <p:grpSpPr/>
-      <p:pic>
-        <p:nvPicPr>
-          <p:cNvPr id="2" name="Picture 1" descr="S10.png"/>
-          <p:cNvPicPr>
-            <a:picLocks noChangeAspect="1"/>
-          </p:cNvPicPr>
-          <p:nvPr/>
-        </p:nvPicPr>
-        <p:blipFill>
-          <a:blip r:embed="rId2"/>
-          <a:stretch>
-            <a:fillRect/>
-          </a:stretch>
-        </p:blipFill>
-        <p:spPr>
-          <a:xfrm>
-            <a:off x="0" y="0"/>
-            <a:ext cx="12191999" cy="6858000"/>
-          </a:xfrm>
-          <a:prstGeom prst="rect">
-            <a:avLst/>
-          </a:prstGeom>
-        </p:spPr>
-      </p:pic>
-    </p:spTree>
-  </p:cSld>
-  <p:clrMapOvr>
-    <a:masterClrMapping/>
-  </p:clrMapOvr>
-</p:sld>
-</file>
-
-<file path=ppt/slides/slide11.xml><?xml version="1.0" encoding="utf-8"?>
-<p:sld xmlns:a="http://schemas.openxmlformats.org/drawingml/2006/main" xmlns:p="http://schemas.openxmlformats.org/presentationml/2006/main" xmlns:r="http://schemas.openxmlformats.org/officeDocument/2006/relationships">
-  <p:cSld>
-    <p:spTree>
-      <p:nvGrpSpPr>
-        <p:cNvPr id="1" name=""/>
-        <p:cNvGrpSpPr/>
-        <p:nvPr/>
-      </p:nvGrpSpPr>
-      <p:grpSpPr/>
-      <p:pic>
-        <p:nvPicPr>
-          <p:cNvPr id="2" name="Picture 1" descr="S11.png"/>
-          <p:cNvPicPr>
-            <a:picLocks noChangeAspect="1"/>
-          </p:cNvPicPr>
-          <p:nvPr/>
-        </p:nvPicPr>
-        <p:blipFill>
-          <a:blip r:embed="rId2"/>
-          <a:stretch>
-            <a:fillRect/>
-          </a:stretch>
-        </p:blipFill>
-        <p:spPr>
-          <a:xfrm>
-            <a:off x="0" y="0"/>
-            <a:ext cx="12191999" cy="6858000"/>
-          </a:xfrm>
-          <a:prstGeom prst="rect">
-            <a:avLst/>
-          </a:prstGeom>
-        </p:spPr>
-      </p:pic>
-    </p:spTree>
-  </p:cSld>
-  <p:clrMapOvr>
-    <a:masterClrMapping/>
-  </p:clrMapOvr>
-</p:sld>
-</file>
-
-<file path=ppt/slides/slide12.xml><?xml version="1.0" encoding="utf-8"?>
-<p:sld xmlns:a="http://schemas.openxmlformats.org/drawingml/2006/main" xmlns:p="http://schemas.openxmlformats.org/presentationml/2006/main" xmlns:r="http://schemas.openxmlformats.org/officeDocument/2006/relationships">
-  <p:cSld>
-    <p:spTree>
-      <p:nvGrpSpPr>
-        <p:cNvPr id="1" name=""/>
-        <p:cNvGrpSpPr/>
-        <p:nvPr/>
-      </p:nvGrpSpPr>
-      <p:grpSpPr/>
-      <p:pic>
-        <p:nvPicPr>
-          <p:cNvPr id="2" name="Picture 1" descr="S12.png"/>
-          <p:cNvPicPr>
-            <a:picLocks noChangeAspect="1"/>
-          </p:cNvPicPr>
-          <p:nvPr/>
-        </p:nvPicPr>
-        <p:blipFill>
-          <a:blip r:embed="rId2"/>
-          <a:stretch>
-            <a:fillRect/>
-          </a:stretch>
-        </p:blipFill>
-        <p:spPr>
-          <a:xfrm>
-            <a:off x="0" y="0"/>
-            <a:ext cx="12191999" cy="6858000"/>
-          </a:xfrm>
-          <a:prstGeom prst="rect">
-            <a:avLst/>
-          </a:prstGeom>
-        </p:spPr>
-      </p:pic>
-    </p:spTree>
-  </p:cSld>
-  <p:clrMapOvr>
-    <a:masterClrMapping/>
-  </p:clrMapOvr>
-</p:sld>
-</file>
-
-<file path=ppt/slides/slide13.xml><?xml version="1.0" encoding="utf-8"?>
-<p:sld xmlns:a="http://schemas.openxmlformats.org/drawingml/2006/main" xmlns:p="http://schemas.openxmlformats.org/presentationml/2006/main" xmlns:r="http://schemas.openxmlformats.org/officeDocument/2006/relationships">
-  <p:cSld>
-    <p:spTree>
-      <p:nvGrpSpPr>
-        <p:cNvPr id="1" name=""/>
-        <p:cNvGrpSpPr/>
-        <p:nvPr/>
-      </p:nvGrpSpPr>
-      <p:grpSpPr/>
-      <p:pic>
-        <p:nvPicPr>
-          <p:cNvPr id="2" name="Picture 1" descr="S13.png"/>
-          <p:cNvPicPr>
-            <a:picLocks noChangeAspect="1"/>
-          </p:cNvPicPr>
-          <p:nvPr/>
-        </p:nvPicPr>
-        <p:blipFill>
-          <a:blip r:embed="rId2"/>
-          <a:stretch>
-            <a:fillRect/>
-          </a:stretch>
-        </p:blipFill>
-        <p:spPr>
-          <a:xfrm>
-            <a:off x="0" y="0"/>
-            <a:ext cx="12191999" cy="6858000"/>
-          </a:xfrm>
-          <a:prstGeom prst="rect">
-            <a:avLst/>
-          </a:prstGeom>
-        </p:spPr>
-      </p:pic>
-    </p:spTree>
-  </p:cSld>
-  <p:clrMapOvr>
-    <a:masterClrMapping/>
-  </p:clrMapOvr>
-</p:sld>
-</file>
-
-<file path=ppt/slides/slide14.xml><?xml version="1.0" encoding="utf-8"?>
-<p:sld xmlns:a="http://schemas.openxmlformats.org/drawingml/2006/main" xmlns:p="http://schemas.openxmlformats.org/presentationml/2006/main" xmlns:r="http://schemas.openxmlformats.org/officeDocument/2006/relationships">
-  <p:cSld>
-    <p:spTree>
-      <p:nvGrpSpPr>
-        <p:cNvPr id="1" name=""/>
-        <p:cNvGrpSpPr/>
-        <p:nvPr/>
-      </p:nvGrpSpPr>
-      <p:grpSpPr/>
-      <p:pic>
-        <p:nvPicPr>
-          <p:cNvPr id="2" name="Picture 1" descr="S14.png"/>
-          <p:cNvPicPr>
-            <a:picLocks noChangeAspect="1"/>
-          </p:cNvPicPr>
-          <p:nvPr/>
-        </p:nvPicPr>
-        <p:blipFill>
-          <a:blip r:embed="rId2"/>
-          <a:stretch>
-            <a:fillRect/>
-          </a:stretch>
-        </p:blipFill>
-        <p:spPr>
-          <a:xfrm>
-            <a:off x="0" y="0"/>
-            <a:ext cx="12191999" cy="6858000"/>
-          </a:xfrm>
-          <a:prstGeom prst="rect">
-            <a:avLst/>
-          </a:prstGeom>
-        </p:spPr>
-      </p:pic>
-    </p:spTree>
-  </p:cSld>
-  <p:clrMapOvr>
-    <a:masterClrMapping/>
-  </p:clrMapOvr>
-</p:sld>
-</file>
-
-<file path=ppt/slides/slide15.xml><?xml version="1.0" encoding="utf-8"?>
-<p:sld xmlns:a="http://schemas.openxmlformats.org/drawingml/2006/main" xmlns:p="http://schemas.openxmlformats.org/presentationml/2006/main" xmlns:r="http://schemas.openxmlformats.org/officeDocument/2006/relationships">
-  <p:cSld>
-    <p:spTree>
-      <p:nvGrpSpPr>
-        <p:cNvPr id="1" name=""/>
-        <p:cNvGrpSpPr/>
-        <p:nvPr/>
-      </p:nvGrpSpPr>
-      <p:grpSpPr/>
-      <p:pic>
-        <p:nvPicPr>
-          <p:cNvPr id="2" name="Picture 1" descr="S15.png"/>
-          <p:cNvPicPr>
-            <a:picLocks noChangeAspect="1"/>
-          </p:cNvPicPr>
-          <p:nvPr/>
-        </p:nvPicPr>
-        <p:blipFill>
-          <a:blip r:embed="rId2"/>
-          <a:stretch>
-            <a:fillRect/>
-          </a:stretch>
-        </p:blipFill>
-        <p:spPr>
-          <a:xfrm>
-            <a:off x="0" y="0"/>
-            <a:ext cx="12191999" cy="6858000"/>
-          </a:xfrm>
-          <a:prstGeom prst="rect">
-            <a:avLst/>
-          </a:prstGeom>
-        </p:spPr>
-      </p:pic>
-    </p:spTree>
-  </p:cSld>
-  <p:clrMapOvr>
-    <a:masterClrMapping/>
-  </p:clrMapOvr>
-</p:sld>
-</file>
-
-<file path=ppt/slides/slide16.xml><?xml version="1.0" encoding="utf-8"?>
-<p:sld xmlns:a="http://schemas.openxmlformats.org/drawingml/2006/main" xmlns:p="http://schemas.openxmlformats.org/presentationml/2006/main" xmlns:r="http://schemas.openxmlformats.org/officeDocument/2006/relationships">
-  <p:cSld>
-    <p:spTree>
-      <p:nvGrpSpPr>
-        <p:cNvPr id="1" name=""/>
-        <p:cNvGrpSpPr/>
-        <p:nvPr/>
-      </p:nvGrpSpPr>
-      <p:grpSpPr/>
-      <p:pic>
-        <p:nvPicPr>
-          <p:cNvPr id="2" name="Picture 1" descr="S16.png"/>
-          <p:cNvPicPr>
-            <a:picLocks noChangeAspect="1"/>
-          </p:cNvPicPr>
-          <p:nvPr/>
-        </p:nvPicPr>
-        <p:blipFill>
-          <a:blip r:embed="rId2"/>
-          <a:stretch>
-            <a:fillRect/>
-          </a:stretch>
-        </p:blipFill>
-        <p:spPr>
-          <a:xfrm>
-            <a:off x="0" y="0"/>
-            <a:ext cx="12191999" cy="6858000"/>
-          </a:xfrm>
-          <a:prstGeom prst="rect">
-            <a:avLst/>
-          </a:prstGeom>
-        </p:spPr>
-      </p:pic>
-    </p:spTree>
-  </p:cSld>
-  <p:clrMapOvr>
-    <a:masterClrMapping/>
-  </p:clrMapOvr>
-</p:sld>
-</file>
-
-<file path=ppt/slides/slide17.xml><?xml version="1.0" encoding="utf-8"?>
-<p:sld xmlns:a="http://schemas.openxmlformats.org/drawingml/2006/main" xmlns:p="http://schemas.openxmlformats.org/presentationml/2006/main" xmlns:r="http://schemas.openxmlformats.org/officeDocument/2006/relationships">
-  <p:cSld>
-    <p:spTree>
-      <p:nvGrpSpPr>
-        <p:cNvPr id="1" name=""/>
-        <p:cNvGrpSpPr/>
-        <p:nvPr/>
-      </p:nvGrpSpPr>
-      <p:grpSpPr/>
-      <p:pic>
-        <p:nvPicPr>
-          <p:cNvPr id="2" name="Picture 1" descr="S17.png"/>
-          <p:cNvPicPr>
-            <a:picLocks noChangeAspect="1"/>
-          </p:cNvPicPr>
-          <p:nvPr/>
-        </p:nvPicPr>
-        <p:blipFill>
-          <a:blip r:embed="rId2"/>
-          <a:stretch>
-            <a:fillRect/>
-          </a:stretch>
-        </p:blipFill>
-        <p:spPr>
-          <a:xfrm>
-            <a:off x="0" y="0"/>
-            <a:ext cx="12191999" cy="6858000"/>
-          </a:xfrm>
-          <a:prstGeom prst="rect">
-            <a:avLst/>
-          </a:prstGeom>
-        </p:spPr>
-      </p:pic>
-    </p:spTree>
-  </p:cSld>
-  <p:clrMapOvr>
-    <a:masterClrMapping/>
-  </p:clrMapOvr>
-</p:sld>
-</file>
-
-<file path=ppt/slides/slide18.xml><?xml version="1.0" encoding="utf-8"?>
-<p:sld xmlns:a="http://schemas.openxmlformats.org/drawingml/2006/main" xmlns:p="http://schemas.openxmlformats.org/presentationml/2006/main" xmlns:r="http://schemas.openxmlformats.org/officeDocument/2006/relationships">
-  <p:cSld>
-    <p:spTree>
-      <p:nvGrpSpPr>
-        <p:cNvPr id="1" name=""/>
-        <p:cNvGrpSpPr/>
-        <p:nvPr/>
-      </p:nvGrpSpPr>
-      <p:grpSpPr/>
-      <p:pic>
-        <p:nvPicPr>
-          <p:cNvPr id="2" name="Picture 1" descr="S18.png"/>
-          <p:cNvPicPr>
-            <a:picLocks noChangeAspect="1"/>
-          </p:cNvPicPr>
-          <p:nvPr/>
-        </p:nvPicPr>
-        <p:blipFill>
-          <a:blip r:embed="rId2"/>
-          <a:stretch>
-            <a:fillRect/>
-          </a:stretch>
-        </p:blipFill>
-        <p:spPr>
-          <a:xfrm>
-            <a:off x="0" y="0"/>
-            <a:ext cx="12191999" cy="6858000"/>
-          </a:xfrm>
-          <a:prstGeom prst="rect">
-            <a:avLst/>
-          </a:prstGeom>
-        </p:spPr>
-      </p:pic>
+      <p:sp>
+        <p:nvSpPr>
+          <p:cNvPr id="2" name="Title 1"/>
+          <p:cNvSpPr>
+            <a:spLocks noGrp="1"/>
+          </p:cNvSpPr>
+          <p:nvPr>
+            <p:ph type="ctrTitle"/>
+          </p:nvPr>
+        </p:nvSpPr>
+        <p:spPr/>
+        <p:txBody>
+          <a:bodyPr/>
+          <a:lstStyle/>
+          <a:p>
+            <a:r>
+              <a:t>摸鱼 · 校园购物 + 二手交易平台</a:t>
+            </a:r>
+          </a:p>
+        </p:txBody>
+      </p:sp>
+      <p:sp>
+        <p:nvSpPr>
+          <p:cNvPr id="3" name="Subtitle 2"/>
+          <p:cNvSpPr>
+            <a:spLocks noGrp="1"/>
+          </p:cNvSpPr>
+          <p:nvPr>
+            <p:ph type="subTitle" idx="1"/>
+          </p:nvPr>
+        </p:nvSpPr>
+        <p:spPr/>
+        <p:txBody>
+          <a:bodyPr/>
+          <a:lstStyle/>
+          <a:p>
+            <a:pPr/>
+            <a:r>
+              <a:rPr sz="2000" b="0">
+                <a:latin typeface="Microsoft YaHei"/>
+              </a:rPr>
+              <a:t>软件工程基础实践 2026 夏  ·  杨任宇老师班 13组</a:t>
+            </a:r>
+          </a:p>
+          <a:p>
+            <a:pPr/>
+            <a:r>
+              <a:rPr sz="2000" b="0">
+                <a:latin typeface="Microsoft YaHei"/>
+              </a:rPr>
+              <a:t>https://github.com/tchen-0213/softw</a:t>
+            </a:r>
+          </a:p>
+          <a:p>
+            <a:pPr/>
+            <a:r>
+              <a:rPr sz="2000" b="0">
+                <a:latin typeface="Microsoft YaHei"/>
+              </a:rPr>
+              <a:t>鲁在精  浦灵一  王悠然  赵紫嫣  陈子正  剧博洋</a:t>
+            </a:r>
+          </a:p>
+          <a:p>
+            <a:pPr/>
+            <a:r>
+              <a:rPr sz="2000" b="0">
+                <a:latin typeface="Microsoft YaHei"/>
+              </a:rPr>
+              <a:t>本页起约 3 分钟讲项目与架构；现场演示播放录屏</a:t>
+            </a:r>
+          </a:p>
+        </p:txBody>
+      </p:sp>
     </p:spTree>
   </p:cSld>
   <p:clrMapOvr>
@@ -5135,30 +3185,100 @@
         <p:nvPr/>
       </p:nvGrpSpPr>
       <p:grpSpPr/>
-      <p:pic>
-        <p:nvPicPr>
-          <p:cNvPr id="2" name="Picture 1" descr="S02.png"/>
-          <p:cNvPicPr>
-            <a:picLocks noChangeAspect="1"/>
-          </p:cNvPicPr>
-          <p:nvPr/>
-        </p:nvPicPr>
-        <p:blipFill>
-          <a:blip r:embed="rId2"/>
-          <a:stretch>
-            <a:fillRect/>
-          </a:stretch>
-        </p:blipFill>
-        <p:spPr>
-          <a:xfrm>
-            <a:off x="0" y="0"/>
-            <a:ext cx="12191999" cy="6858000"/>
-          </a:xfrm>
-          <a:prstGeom prst="rect">
-            <a:avLst/>
-          </a:prstGeom>
-        </p:spPr>
-      </p:pic>
+      <p:sp>
+        <p:nvSpPr>
+          <p:cNvPr id="2" name="Title 1"/>
+          <p:cNvSpPr>
+            <a:spLocks noGrp="1"/>
+          </p:cNvSpPr>
+          <p:nvPr>
+            <p:ph type="title"/>
+          </p:nvPr>
+        </p:nvSpPr>
+        <p:spPr/>
+        <p:txBody>
+          <a:bodyPr/>
+          <a:lstStyle/>
+          <a:p>
+            <a:r>
+              <a:rPr sz="2800" b="1">
+                <a:latin typeface="Microsoft YaHei"/>
+              </a:rPr>
+              <a:t>项目目标与全部业务场景（UC01–UC12 均完成）</a:t>
+            </a:r>
+          </a:p>
+        </p:txBody>
+      </p:sp>
+      <p:sp>
+        <p:nvSpPr>
+          <p:cNvPr id="3" name="Content Placeholder 2"/>
+          <p:cNvSpPr>
+            <a:spLocks noGrp="1"/>
+          </p:cNvSpPr>
+          <p:nvPr>
+            <p:ph idx="1"/>
+          </p:nvPr>
+        </p:nvSpPr>
+        <p:spPr/>
+        <p:txBody>
+          <a:bodyPr/>
+          <a:lstStyle/>
+          <a:p>
+            <a:pPr/>
+            <a:r>
+              <a:rPr sz="1800" b="0">
+                <a:latin typeface="Microsoft YaHei"/>
+              </a:rPr>
+              <a:t>校园购物+二手。原系统 React + 一个 Express + MySQL shopping_platform；标签 monolith-start（10fa639）</a:t>
+            </a:r>
+          </a:p>
+          <a:p>
+            <a:pPr/>
+            <a:r>
+              <a:rPr sz="1800" b="0">
+                <a:latin typeface="Microsoft YaHei"/>
+              </a:rPr>
+              <a:t>小学期：Docker 三容器、GitHub Actions、K8s YAML、三业务微服务+网关；标签 microservices-v1（63585e0）</a:t>
+            </a:r>
+          </a:p>
+          <a:p>
+            <a:pPr/>
+            <a:r>
+              <a:rPr sz="1800" b="0">
+                <a:latin typeface="Microsoft YaHei"/>
+              </a:rPr>
+              <a:t>端口：单体 8080/3001；微服务前端 8082、网关 8081</a:t>
+            </a:r>
+          </a:p>
+          <a:p>
+            <a:pPr/>
+            <a:r>
+              <a:rPr sz="1800" b="0">
+                <a:latin typeface="Microsoft YaHei"/>
+              </a:rPr>
+              <a:t>UC01 注册登录（重点）  UC02 搜索（重点）  UC03 详情加购  UC04 下单履约（重点）</a:t>
+            </a:r>
+          </a:p>
+          <a:p>
+            <a:pPr/>
+            <a:r>
+              <a:rPr sz="1800" b="0">
+                <a:latin typeface="Microsoft YaHei"/>
+              </a:rPr>
+              <a:t>UC05 二手  UC06 店铺  UC07 评价  UC08 议价  UC09 地址  UC10 物流  UC11 取消恢复库存  UC12 公开店铺</a:t>
+            </a:r>
+          </a:p>
+          <a:p>
+            <a:pPr/>
+            <a:r>
+              <a:rPr sz="1800" b="0">
+                <a:latin typeface="Microsoft YaHei"/>
+              </a:rPr>
+              <a:t>重点三条不等于只做了三条；UC10–UC12 终期纳入追溯</a:t>
+            </a:r>
+          </a:p>
+        </p:txBody>
+      </p:sp>
     </p:spTree>
   </p:cSld>
   <p:clrMapOvr>
@@ -5177,30 +3297,100 @@
         <p:nvPr/>
       </p:nvGrpSpPr>
       <p:grpSpPr/>
-      <p:pic>
-        <p:nvPicPr>
-          <p:cNvPr id="2" name="Picture 1" descr="S03.png"/>
-          <p:cNvPicPr>
-            <a:picLocks noChangeAspect="1"/>
-          </p:cNvPicPr>
-          <p:nvPr/>
-        </p:nvPicPr>
-        <p:blipFill>
-          <a:blip r:embed="rId2"/>
-          <a:stretch>
-            <a:fillRect/>
-          </a:stretch>
-        </p:blipFill>
-        <p:spPr>
-          <a:xfrm>
-            <a:off x="0" y="0"/>
-            <a:ext cx="12191999" cy="6858000"/>
-          </a:xfrm>
-          <a:prstGeom prst="rect">
-            <a:avLst/>
-          </a:prstGeom>
-        </p:spPr>
-      </p:pic>
+      <p:sp>
+        <p:nvSpPr>
+          <p:cNvPr id="2" name="Title 1"/>
+          <p:cNvSpPr>
+            <a:spLocks noGrp="1"/>
+          </p:cNvSpPr>
+          <p:nvPr>
+            <p:ph type="title"/>
+          </p:nvPr>
+        </p:nvSpPr>
+        <p:spPr/>
+        <p:txBody>
+          <a:bodyPr/>
+          <a:lstStyle/>
+          <a:p>
+            <a:r>
+              <a:rPr sz="2800" b="1">
+                <a:latin typeface="Microsoft YaHei"/>
+              </a:rPr>
+              <a:t>代表用例：需求—设计—代码—测试（模型到代码）</a:t>
+            </a:r>
+          </a:p>
+        </p:txBody>
+      </p:sp>
+      <p:sp>
+        <p:nvSpPr>
+          <p:cNvPr id="3" name="Content Placeholder 2"/>
+          <p:cNvSpPr>
+            <a:spLocks noGrp="1"/>
+          </p:cNvSpPr>
+          <p:nvPr>
+            <p:ph idx="1"/>
+          </p:nvPr>
+        </p:nvSpPr>
+        <p:spPr/>
+        <p:txBody>
+          <a:bodyPr/>
+          <a:lstStyle/>
+          <a:p>
+            <a:pPr/>
+            <a:r>
+              <a:rPr sz="1700" b="0">
+                <a:latin typeface="Microsoft YaHei"/>
+              </a:rPr>
+              <a:t>UC01 SYS/COMP/OBJ-SEQ01 → user.js userController AuthPage → UNIT/INT/E2E-TC01</a:t>
+            </a:r>
+          </a:p>
+          <a:p>
+            <a:pPr/>
+            <a:r>
+              <a:rPr sz="1700" b="0">
+                <a:latin typeface="Microsoft YaHei"/>
+              </a:rPr>
+              <a:t>UC02 SYS/COMP/OBJ-SEQ02 → product.js productController SearchPage → UNIT/INT/E2E-TC02</a:t>
+            </a:r>
+          </a:p>
+          <a:p>
+            <a:pPr/>
+            <a:r>
+              <a:rPr sz="1700" b="0">
+                <a:latin typeface="Microsoft YaHei"/>
+              </a:rPr>
+              <a:t>UC04 SYS/COMP/OBJ-SEQ04 → order.js orderController CheckoutPage → UNIT/INT/E2E-TC04</a:t>
+            </a:r>
+          </a:p>
+          <a:p>
+            <a:pPr/>
+            <a:r>
+              <a:rPr sz="1700" b="0">
+                <a:latin typeface="Microsoft YaHei"/>
+              </a:rPr>
+              <a:t>UC04：需求下单支付发货收货 → 组件级页面/鉴权/控制器/事务 → 对象级 createOrder()、pay/ship/confirm</a:t>
+            </a:r>
+          </a:p>
+          <a:p>
+            <a:pPr/>
+            <a:r>
+              <a:rPr sz="1700" b="0">
+                <a:latin typeface="Microsoft YaHei"/>
+              </a:rPr>
+              <a:t>状态 待付款→待发货→待收货→已完成；order-service 按 reservationId 调 product-service 预留/释放/完成</a:t>
+            </a:r>
+          </a:p>
+          <a:p>
+            <a:pPr/>
+            <a:r>
+              <a:rPr sz="1700" b="0">
+                <a:latin typeface="Microsoft YaHei"/>
+              </a:rPr>
+              <a:t>系统级不出现 Controller；对象级到函数名。图用仓库 PNG 原图，不要重绘</a:t>
+            </a:r>
+          </a:p>
+        </p:txBody>
+      </p:sp>
     </p:spTree>
   </p:cSld>
   <p:clrMapOvr>
@@ -5219,30 +3409,100 @@
         <p:nvPr/>
       </p:nvGrpSpPr>
       <p:grpSpPr/>
-      <p:pic>
-        <p:nvPicPr>
-          <p:cNvPr id="2" name="Picture 1" descr="S04.png"/>
-          <p:cNvPicPr>
-            <a:picLocks noChangeAspect="1"/>
-          </p:cNvPicPr>
-          <p:nvPr/>
-        </p:nvPicPr>
-        <p:blipFill>
-          <a:blip r:embed="rId2"/>
-          <a:stretch>
-            <a:fillRect/>
-          </a:stretch>
-        </p:blipFill>
-        <p:spPr>
-          <a:xfrm>
-            <a:off x="0" y="0"/>
-            <a:ext cx="12191999" cy="6858000"/>
-          </a:xfrm>
-          <a:prstGeom prst="rect">
-            <a:avLst/>
-          </a:prstGeom>
-        </p:spPr>
-      </p:pic>
+      <p:sp>
+        <p:nvSpPr>
+          <p:cNvPr id="2" name="Title 1"/>
+          <p:cNvSpPr>
+            <a:spLocks noGrp="1"/>
+          </p:cNvSpPr>
+          <p:nvPr>
+            <p:ph type="title"/>
+          </p:nvPr>
+        </p:nvSpPr>
+        <p:spPr/>
+        <p:txBody>
+          <a:bodyPr/>
+          <a:lstStyle/>
+          <a:p>
+            <a:r>
+              <a:rPr sz="2800" b="1">
+                <a:latin typeface="Microsoft YaHei"/>
+              </a:rPr>
+              <a:t>三个业务微服务：职责、划分、接口、表、失败处理</a:t>
+            </a:r>
+          </a:p>
+        </p:txBody>
+      </p:sp>
+      <p:sp>
+        <p:nvSpPr>
+          <p:cNvPr id="3" name="Content Placeholder 2"/>
+          <p:cNvSpPr>
+            <a:spLocks noGrp="1"/>
+          </p:cNvSpPr>
+          <p:nvPr>
+            <p:ph idx="1"/>
+          </p:nvPr>
+        </p:nvSpPr>
+        <p:spPr/>
+        <p:txBody>
+          <a:bodyPr/>
+          <a:lstStyle/>
+          <a:p>
+            <a:pPr/>
+            <a:r>
+              <a:rPr sz="1600" b="0">
+                <a:latin typeface="Microsoft YaHei"/>
+              </a:rPr>
+              <a:t>前端→API Gateway（不算业务服务）→ user / product / order；按身份/标的/交易过程拆，不是 12 个服务</a:t>
+            </a:r>
+          </a:p>
+          <a:p>
+            <a:pPr/>
+            <a:r>
+              <a:rPr sz="1600" b="0">
+                <a:latin typeface="Microsoft YaHei"/>
+              </a:rPr>
+              <a:t>user-service → softw_users（Users, Addresses）  注册登录资料密码地址角色信用</a:t>
+            </a:r>
+          </a:p>
+          <a:p>
+            <a:pPr/>
+            <a:r>
+              <a:rPr sz="1600" b="0">
+                <a:latin typeface="Microsoft YaHei"/>
+              </a:rPr>
+              <a:t>product-service → softw_catalog + uploads  商品二手店铺评价聊天议价图片库存</a:t>
+            </a:r>
+          </a:p>
+          <a:p>
+            <a:pPr/>
+            <a:r>
+              <a:rPr sz="1600" b="0">
+                <a:latin typeface="Microsoft YaHei"/>
+              </a:rPr>
+              <a:t>order-service → softw_orders（Orders）  下单支付取消发货收货；订单存快照，不跨库联表</a:t>
+            </a:r>
+          </a:p>
+          <a:p>
+            <a:pPr/>
+            <a:r>
+              <a:rPr sz="1600" b="0">
+                <a:latin typeface="Microsoft YaHei"/>
+              </a:rPr>
+              <a:t>网关：/api/users,/api/addresses→user；商品/二手/店/评价/聊天/上传→product；/api/orders→order</a:t>
+            </a:r>
+          </a:p>
+          <a:p>
+            <a:pPr/>
+            <a:r>
+              <a:rPr sz="1600" b="0">
+                <a:latin typeface="Microsoft YaHei"/>
+              </a:rPr>
+              <a:t>失败：网关超时 503 不伪造；预留失败不下单；幂等 reservationId；停商品服务：商品 503、订单 206，其它仍存活</a:t>
+            </a:r>
+          </a:p>
+        </p:txBody>
+      </p:sp>
     </p:spTree>
   </p:cSld>
   <p:clrMapOvr>
@@ -5261,30 +3521,91 @@
         <p:nvPr/>
       </p:nvGrpSpPr>
       <p:grpSpPr/>
-      <p:pic>
-        <p:nvPicPr>
-          <p:cNvPr id="2" name="Picture 1" descr="S05.png"/>
-          <p:cNvPicPr>
-            <a:picLocks noChangeAspect="1"/>
-          </p:cNvPicPr>
-          <p:nvPr/>
-        </p:nvPicPr>
-        <p:blipFill>
-          <a:blip r:embed="rId2"/>
-          <a:stretch>
-            <a:fillRect/>
-          </a:stretch>
-        </p:blipFill>
-        <p:spPr>
-          <a:xfrm>
-            <a:off x="0" y="0"/>
-            <a:ext cx="12191999" cy="6858000"/>
-          </a:xfrm>
-          <a:prstGeom prst="rect">
-            <a:avLst/>
-          </a:prstGeom>
-        </p:spPr>
-      </p:pic>
+      <p:sp>
+        <p:nvSpPr>
+          <p:cNvPr id="2" name="Title 1"/>
+          <p:cNvSpPr>
+            <a:spLocks noGrp="1"/>
+          </p:cNvSpPr>
+          <p:nvPr>
+            <p:ph type="title"/>
+          </p:nvPr>
+        </p:nvSpPr>
+        <p:spPr/>
+        <p:txBody>
+          <a:bodyPr/>
+          <a:lstStyle/>
+          <a:p>
+            <a:r>
+              <a:rPr sz="2800" b="1">
+                <a:latin typeface="Microsoft YaHei"/>
+              </a:rPr>
+              <a:t>关键数据（2026-09-03 二阶段；性能 2026-08-28）</a:t>
+            </a:r>
+          </a:p>
+        </p:txBody>
+      </p:sp>
+      <p:sp>
+        <p:nvSpPr>
+          <p:cNvPr id="3" name="Content Placeholder 2"/>
+          <p:cNvSpPr>
+            <a:spLocks noGrp="1"/>
+          </p:cNvSpPr>
+          <p:nvPr>
+            <p:ph idx="1"/>
+          </p:nvPr>
+        </p:nvSpPr>
+        <p:spPr/>
+        <p:txBody>
+          <a:bodyPr/>
+          <a:lstStyle/>
+          <a:p>
+            <a:pPr/>
+            <a:r>
+              <a:rPr sz="1600" b="0">
+                <a:latin typeface="Microsoft YaHei"/>
+              </a:rPr>
+              <a:t>后端 220 通过/0 失败/1 跳过（含 REG-BE 100/100）；前端原有 100/100，REG-FE 待 Vitest 复跑</a:t>
+            </a:r>
+          </a:p>
+          <a:p>
+            <a:pPr/>
+            <a:r>
+              <a:rPr sz="1600" b="0">
+                <a:latin typeface="Microsoft YaHei"/>
+              </a:rPr>
+              <a:t>覆盖率 94.42%/81.83%/92.34%/94.42%；API 32/32；E2E 两侧 42/42；微服务 18/18、22/22、15/15；49 项公开 API</a:t>
+            </a:r>
+          </a:p>
+          <a:p>
+            <a:pPr/>
+            <a:r>
+              <a:rPr sz="1600" b="0">
+                <a:latin typeface="Microsoft YaHei"/>
+              </a:rPr>
+              <a:t>CI softw-ci-cd：先测后 7 镜像+Kind；测失败不发版；绿勾 Actions #77（33579985248）</a:t>
+            </a:r>
+          </a:p>
+          <a:p>
+            <a:pPr/>
+            <a:r>
+              <a:rPr sz="1600" b="0">
+                <a:latin typeface="Microsoft YaHei"/>
+              </a:rPr>
+              <a:t>列表吞吐 +61.9%、延迟 −38.6%、CPU +55.2%（搜索/详情见文案表）。禁止写「微服务天然更快」</a:t>
+            </a:r>
+          </a:p>
+          <a:p>
+            <a:pPr/>
+            <a:r>
+              <a:rPr sz="1600" b="0">
+                <a:latin typeface="Microsoft YaHei"/>
+              </a:rPr>
+              <a:t>HPA 1→3→5→1（不放进 CI/CD）；停 product-service：503 / 206，恢复无残留</a:t>
+            </a:r>
+          </a:p>
+        </p:txBody>
+      </p:sp>
     </p:spTree>
   </p:cSld>
   <p:clrMapOvr>
@@ -5303,30 +3624,73 @@
         <p:nvPr/>
       </p:nvGrpSpPr>
       <p:grpSpPr/>
-      <p:pic>
-        <p:nvPicPr>
-          <p:cNvPr id="2" name="Picture 1" descr="S06.png"/>
-          <p:cNvPicPr>
-            <a:picLocks noChangeAspect="1"/>
-          </p:cNvPicPr>
-          <p:nvPr/>
-        </p:nvPicPr>
-        <p:blipFill>
-          <a:blip r:embed="rId2"/>
-          <a:stretch>
-            <a:fillRect/>
-          </a:stretch>
-        </p:blipFill>
-        <p:spPr>
-          <a:xfrm>
-            <a:off x="0" y="0"/>
-            <a:ext cx="12191999" cy="6858000"/>
-          </a:xfrm>
-          <a:prstGeom prst="rect">
-            <a:avLst/>
-          </a:prstGeom>
-        </p:spPr>
-      </p:pic>
+      <p:sp>
+        <p:nvSpPr>
+          <p:cNvPr id="2" name="Title 1"/>
+          <p:cNvSpPr>
+            <a:spLocks noGrp="1"/>
+          </p:cNvSpPr>
+          <p:nvPr>
+            <p:ph type="title"/>
+          </p:nvPr>
+        </p:nvSpPr>
+        <p:spPr/>
+        <p:txBody>
+          <a:bodyPr/>
+          <a:lstStyle/>
+          <a:p>
+            <a:r>
+              <a:rPr sz="2800" b="1">
+                <a:latin typeface="Microsoft YaHei"/>
+              </a:rPr>
+              <a:t>分工与大模型</a:t>
+            </a:r>
+          </a:p>
+        </p:txBody>
+      </p:sp>
+      <p:sp>
+        <p:nvSpPr>
+          <p:cNvPr id="3" name="Content Placeholder 2"/>
+          <p:cNvSpPr>
+            <a:spLocks noGrp="1"/>
+          </p:cNvSpPr>
+          <p:nvPr>
+            <p:ph idx="1"/>
+          </p:nvPr>
+        </p:nvSpPr>
+        <p:spPr/>
+        <p:txBody>
+          <a:bodyPr/>
+          <a:lstStyle/>
+          <a:p>
+            <a:pPr/>
+            <a:r>
+              <a:rPr sz="1800" b="0">
+                <a:latin typeface="Microsoft YaHei"/>
+              </a:rPr>
+              <a:t>鲁在精 组长/计划协调汇报；浦灵一 后端安全文档；王悠然 前端；赵紫嫣 测试；陈子正 流水线部署；剧博洋 性能</a:t>
+            </a:r>
+          </a:p>
+          <a:p>
+            <a:pPr/>
+            <a:r>
+              <a:rPr sz="1800" b="0">
+                <a:latin typeface="Microsoft YaHei"/>
+              </a:rPr>
+              <a:t>权重待全组确认，不按 commit 换算。GitHub Issues + Project「软工小学期」+ Actions</a:t>
+            </a:r>
+          </a:p>
+          <a:p>
+            <a:pPr/>
+            <a:r>
+              <a:rPr sz="1800" b="0">
+                <a:latin typeface="Microsoft YaHei"/>
+              </a:rPr>
+              <a:t>大模型：检索、测试建议、文档整理、部署检查。人工读代码、真跑测试、对版本、扫凭据。输出不当验收结论</a:t>
+            </a:r>
+          </a:p>
+        </p:txBody>
+      </p:sp>
     </p:spTree>
   </p:cSld>
   <p:clrMapOvr>
@@ -5345,114 +3709,73 @@
         <p:nvPr/>
       </p:nvGrpSpPr>
       <p:grpSpPr/>
-      <p:pic>
-        <p:nvPicPr>
-          <p:cNvPr id="2" name="Picture 1" descr="S07.png"/>
-          <p:cNvPicPr>
-            <a:picLocks noChangeAspect="1"/>
-          </p:cNvPicPr>
-          <p:nvPr/>
-        </p:nvPicPr>
-        <p:blipFill>
-          <a:blip r:embed="rId2"/>
-          <a:stretch>
-            <a:fillRect/>
-          </a:stretch>
-        </p:blipFill>
-        <p:spPr>
-          <a:xfrm>
-            <a:off x="0" y="0"/>
-            <a:ext cx="12191999" cy="6858000"/>
-          </a:xfrm>
-          <a:prstGeom prst="rect">
-            <a:avLst/>
-          </a:prstGeom>
-        </p:spPr>
-      </p:pic>
-    </p:spTree>
-  </p:cSld>
-  <p:clrMapOvr>
-    <a:masterClrMapping/>
-  </p:clrMapOvr>
-</p:sld>
-</file>
-
-<file path=ppt/slides/slide8.xml><?xml version="1.0" encoding="utf-8"?>
-<p:sld xmlns:a="http://schemas.openxmlformats.org/drawingml/2006/main" xmlns:p="http://schemas.openxmlformats.org/presentationml/2006/main" xmlns:r="http://schemas.openxmlformats.org/officeDocument/2006/relationships">
-  <p:cSld>
-    <p:spTree>
-      <p:nvGrpSpPr>
-        <p:cNvPr id="1" name=""/>
-        <p:cNvGrpSpPr/>
-        <p:nvPr/>
-      </p:nvGrpSpPr>
-      <p:grpSpPr/>
-      <p:pic>
-        <p:nvPicPr>
-          <p:cNvPr id="2" name="Picture 1" descr="S08.png"/>
-          <p:cNvPicPr>
-            <a:picLocks noChangeAspect="1"/>
-          </p:cNvPicPr>
-          <p:nvPr/>
-        </p:nvPicPr>
-        <p:blipFill>
-          <a:blip r:embed="rId2"/>
-          <a:stretch>
-            <a:fillRect/>
-          </a:stretch>
-        </p:blipFill>
-        <p:spPr>
-          <a:xfrm>
-            <a:off x="0" y="0"/>
-            <a:ext cx="12191999" cy="6858000"/>
-          </a:xfrm>
-          <a:prstGeom prst="rect">
-            <a:avLst/>
-          </a:prstGeom>
-        </p:spPr>
-      </p:pic>
-    </p:spTree>
-  </p:cSld>
-  <p:clrMapOvr>
-    <a:masterClrMapping/>
-  </p:clrMapOvr>
-</p:sld>
-</file>
-
-<file path=ppt/slides/slide9.xml><?xml version="1.0" encoding="utf-8"?>
-<p:sld xmlns:a="http://schemas.openxmlformats.org/drawingml/2006/main" xmlns:p="http://schemas.openxmlformats.org/presentationml/2006/main" xmlns:r="http://schemas.openxmlformats.org/officeDocument/2006/relationships">
-  <p:cSld>
-    <p:spTree>
-      <p:nvGrpSpPr>
-        <p:cNvPr id="1" name=""/>
-        <p:cNvGrpSpPr/>
-        <p:nvPr/>
-      </p:nvGrpSpPr>
-      <p:grpSpPr/>
-      <p:pic>
-        <p:nvPicPr>
-          <p:cNvPr id="2" name="Picture 1" descr="S09.png"/>
-          <p:cNvPicPr>
-            <a:picLocks noChangeAspect="1"/>
-          </p:cNvPicPr>
-          <p:nvPr/>
-        </p:nvPicPr>
-        <p:blipFill>
-          <a:blip r:embed="rId2"/>
-          <a:stretch>
-            <a:fillRect/>
-          </a:stretch>
-        </p:blipFill>
-        <p:spPr>
-          <a:xfrm>
-            <a:off x="0" y="0"/>
-            <a:ext cx="12191999" cy="6858000"/>
-          </a:xfrm>
-          <a:prstGeom prst="rect">
-            <a:avLst/>
-          </a:prstGeom>
-        </p:spPr>
-      </p:pic>
+      <p:sp>
+        <p:nvSpPr>
+          <p:cNvPr id="2" name="Title 1"/>
+          <p:cNvSpPr>
+            <a:spLocks noGrp="1"/>
+          </p:cNvSpPr>
+          <p:nvPr>
+            <p:ph type="title"/>
+          </p:nvPr>
+        </p:nvSpPr>
+        <p:spPr/>
+        <p:txBody>
+          <a:bodyPr/>
+          <a:lstStyle/>
+          <a:p>
+            <a:r>
+              <a:rPr sz="2800" b="1">
+                <a:latin typeface="Microsoft YaHei"/>
+              </a:rPr>
+              <a:t>接下来播放演示录屏</a:t>
+            </a:r>
+          </a:p>
+        </p:txBody>
+      </p:sp>
+      <p:sp>
+        <p:nvSpPr>
+          <p:cNvPr id="3" name="Content Placeholder 2"/>
+          <p:cNvSpPr>
+            <a:spLocks noGrp="1"/>
+          </p:cNvSpPr>
+          <p:nvPr>
+            <p:ph idx="1"/>
+          </p:nvPr>
+        </p:nvSpPr>
+        <p:spPr/>
+        <p:txBody>
+          <a:bodyPr/>
+          <a:lstStyle/>
+          <a:p>
+            <a:pPr/>
+            <a:r>
+              <a:rPr sz="2000" b="0">
+                <a:latin typeface="Microsoft YaHei"/>
+              </a:rPr>
+              <a:t>现场 4 分钟以录屏为主（可加速；最好配音字幕）</a:t>
+            </a:r>
+          </a:p>
+          <a:p>
+            <a:pPr/>
+            <a:r>
+              <a:rPr sz="2000" b="0">
+                <a:latin typeface="Microsoft YaHei"/>
+              </a:rPr>
+              <a:t>录屏中应能看到：① 提交并触发流水线（#77；失败不进镜像）② kubectl/Pod 网关+三服务</a:t>
+            </a:r>
+          </a:p>
+          <a:p>
+            <a:pPr/>
+            <a:r>
+              <a:rPr sz="2000" b="0">
+                <a:latin typeface="Microsoft YaHei"/>
+              </a:rPr>
+              <a:t>③ UC01→UC02→UC04 及自动化测试 ④ HPA 1→3→5→1（不在 CI/CD）⑤ 停商品服务 503/206，其它仍可用</a:t>
+            </a:r>
+          </a:p>
+        </p:txBody>
+      </p:sp>
     </p:spTree>
   </p:cSld>
   <p:clrMapOvr>
@@ -5779,324 +4102,4 @@
   </a:objectDefaults>
   <a:extraClrSchemeLst/>
 </a:theme>
-</file>
-
-<file path=ppt/theme/theme2.xml><?xml version="1.0" encoding="utf-8"?>
-<a:theme xmlns:a="http://schemas.openxmlformats.org/drawingml/2006/main" name="Office Theme">
-  <a:themeElements>
-    <a:clrScheme name="Office">
-      <a:dk1>
-        <a:sysClr val="windowText" lastClr="000000"/>
-      </a:dk1>
-      <a:lt1>
-        <a:sysClr val="window" lastClr="FFFFFF"/>
-      </a:lt1>
-      <a:dk2>
-        <a:srgbClr val="1F497D"/>
-      </a:dk2>
-      <a:lt2>
-        <a:srgbClr val="EEECE1"/>
-      </a:lt2>
-      <a:accent1>
-        <a:srgbClr val="4F81BD"/>
-      </a:accent1>
-      <a:accent2>
-        <a:srgbClr val="C0504D"/>
-      </a:accent2>
-      <a:accent3>
-        <a:srgbClr val="9BBB59"/>
-      </a:accent3>
-      <a:accent4>
-        <a:srgbClr val="8064A2"/>
-      </a:accent4>
-      <a:accent5>
-        <a:srgbClr val="4BACC6"/>
-      </a:accent5>
-      <a:accent6>
-        <a:srgbClr val="F79646"/>
-      </a:accent6>
-      <a:hlink>
-        <a:srgbClr val="0000FF"/>
-      </a:hlink>
-      <a:folHlink>
-        <a:srgbClr val="800080"/>
-      </a:folHlink>
-    </a:clrScheme>
-    <a:fontScheme name="Office">
-      <a:majorFont>
-        <a:latin typeface="Calibri"/>
-        <a:ea typeface=""/>
-        <a:cs typeface=""/>
-        <a:font script="Jpan" typeface="ＭＳ Ｐゴシック"/>
-        <a:font script="Hang" typeface="맑은 고딕"/>
-        <a:font script="Hans" typeface="宋体"/>
-        <a:font script="Hant" typeface="新細明體"/>
-        <a:font script="Arab" typeface="Times New Roman"/>
-        <a:font script="Hebr" typeface="Times New Roman"/>
-        <a:font script="Thai" typeface="Angsana New"/>
-        <a:font script="Ethi" typeface="Nyala"/>
-        <a:font script="Beng" typeface="Vrinda"/>
-        <a:font script="Gujr" typeface="Shruti"/>
-        <a:font script="Khmr" typeface="MoolBoran"/>
-        <a:font script="Knda" typeface="Tunga"/>
-        <a:font script="Guru" typeface="Raavi"/>
-        <a:font script="Cans" typeface="Euphemia"/>
-        <a:font script="Cher" typeface="Plantagenet Cherokee"/>
-        <a:font script="Yiii" typeface="Microsoft Yi Baiti"/>
-        <a:font script="Tibt" typeface="Microsoft Himalaya"/>
-        <a:font script="Thaa" typeface="MV Boli"/>
-        <a:font script="Deva" typeface="Mangal"/>
-        <a:font script="Telu" typeface="Gautami"/>
-        <a:font script="Taml" typeface="Latha"/>
-        <a:font script="Syrc" typeface="Estrangelo Edessa"/>
-        <a:font script="Orya" typeface="Kalinga"/>
-        <a:font script="Mlym" typeface="Kartika"/>
-        <a:font script="Laoo" typeface="DokChampa"/>
-        <a:font script="Sinh" typeface="Iskoola Pota"/>
-        <a:font script="Mong" typeface="Mongolian Baiti"/>
-        <a:font script="Viet" typeface="Times New Roman"/>
-        <a:font script="Uigh" typeface="Microsoft Uighur"/>
-        <a:font script="Geor" typeface="Sylfaen"/>
-      </a:majorFont>
-      <a:minorFont>
-        <a:latin typeface="Calibri"/>
-        <a:ea typeface=""/>
-        <a:cs typeface=""/>
-        <a:font script="Jpan" typeface="ＭＳ Ｐゴシック"/>
-        <a:font script="Hang" typeface="맑은 고딕"/>
-        <a:font script="Hans" typeface="宋体"/>
-        <a:font script="Hant" typeface="新細明體"/>
-        <a:font script="Arab" typeface="Arial"/>
-        <a:font script="Hebr" typeface="Arial"/>
-        <a:font script="Thai" typeface="Cordia New"/>
-        <a:font script="Ethi" typeface="Nyala"/>
-        <a:font script="Beng" typeface="Vrinda"/>
-        <a:font script="Gujr" typeface="Shruti"/>
-        <a:font script="Khmr" typeface="DaunPenh"/>
-        <a:font script="Knda" typeface="Tunga"/>
-        <a:font script="Guru" typeface="Raavi"/>
-        <a:font script="Cans" typeface="Euphemia"/>
-        <a:font script="Cher" typeface="Plantagenet Cherokee"/>
-        <a:font script="Yiii" typeface="Microsoft Yi Baiti"/>
-        <a:font script="Tibt" typeface="Microsoft Himalaya"/>
-        <a:font script="Thaa" typeface="MV Boli"/>
-        <a:font script="Deva" typeface="Mangal"/>
-        <a:font script="Telu" typeface="Gautami"/>
-        <a:font script="Taml" typeface="Latha"/>
-        <a:font script="Syrc" typeface="Estrangelo Edessa"/>
-        <a:font script="Orya" typeface="Kalinga"/>
-        <a:font script="Mlym" typeface="Kartika"/>
-        <a:font script="Laoo" typeface="DokChampa"/>
-        <a:font script="Sinh" typeface="Iskoola Pota"/>
-        <a:font script="Mong" typeface="Mongolian Baiti"/>
-        <a:font script="Viet" typeface="Arial"/>
-        <a:font script="Uigh" typeface="Microsoft Uighur"/>
-        <a:font script="Geor" typeface="Sylfaen"/>
-      </a:minorFont>
-    </a:fontScheme>
-    <a:fmtScheme name="Office">
-      <a:fillStyleLst>
-        <a:solidFill>
-          <a:schemeClr val="phClr"/>
-        </a:solidFill>
-        <a:gradFill rotWithShape="1">
-          <a:gsLst>
-            <a:gs pos="0">
-              <a:schemeClr val="phClr">
-                <a:tint val="50000"/>
-                <a:satMod val="300000"/>
-              </a:schemeClr>
-            </a:gs>
-            <a:gs pos="35000">
-              <a:schemeClr val="phClr">
-                <a:tint val="37000"/>
-                <a:satMod val="300000"/>
-              </a:schemeClr>
-            </a:gs>
-            <a:gs pos="100000">
-              <a:schemeClr val="phClr">
-                <a:tint val="15000"/>
-                <a:satMod val="350000"/>
-              </a:schemeClr>
-            </a:gs>
-          </a:gsLst>
-          <a:lin ang="16200000" scaled="1"/>
-        </a:gradFill>
-        <a:gradFill rotWithShape="1">
-          <a:gsLst>
-            <a:gs pos="0">
-              <a:schemeClr val="phClr">
-                <a:tint val="100000"/>
-                <a:shade val="100000"/>
-                <a:satMod val="130000"/>
-              </a:schemeClr>
-            </a:gs>
-            <a:gs pos="100000">
-              <a:schemeClr val="phClr">
-                <a:tint val="50000"/>
-                <a:shade val="100000"/>
-                <a:satMod val="350000"/>
-              </a:schemeClr>
-            </a:gs>
-          </a:gsLst>
-          <a:lin ang="16200000" scaled="0"/>
-        </a:gradFill>
-      </a:fillStyleLst>
-      <a:lnStyleLst>
-        <a:ln w="9525" cap="flat" cmpd="sng" algn="ctr">
-          <a:solidFill>
-            <a:schemeClr val="phClr">
-              <a:shade val="95000"/>
-              <a:satMod val="105000"/>
-            </a:schemeClr>
-          </a:solidFill>
-          <a:prstDash val="solid"/>
-        </a:ln>
-        <a:ln w="25400" cap="flat" cmpd="sng" algn="ctr">
-          <a:solidFill>
-            <a:schemeClr val="phClr"/>
-          </a:solidFill>
-          <a:prstDash val="solid"/>
-        </a:ln>
-        <a:ln w="38100" cap="flat" cmpd="sng" algn="ctr">
-          <a:solidFill>
-            <a:schemeClr val="phClr"/>
-          </a:solidFill>
-          <a:prstDash val="solid"/>
-        </a:ln>
-      </a:lnStyleLst>
-      <a:effectStyleLst>
-        <a:effectStyle>
-          <a:effectLst>
-            <a:outerShdw blurRad="40000" dist="20000" dir="5400000" rotWithShape="0">
-              <a:srgbClr val="000000">
-                <a:alpha val="38000"/>
-              </a:srgbClr>
-            </a:outerShdw>
-          </a:effectLst>
-        </a:effectStyle>
-        <a:effectStyle>
-          <a:effectLst>
-            <a:outerShdw blurRad="40000" dist="23000" dir="5400000" rotWithShape="0">
-              <a:srgbClr val="000000">
-                <a:alpha val="35000"/>
-              </a:srgbClr>
-            </a:outerShdw>
-          </a:effectLst>
-        </a:effectStyle>
-        <a:effectStyle>
-          <a:effectLst>
-            <a:outerShdw blurRad="40000" dist="23000" dir="5400000" rotWithShape="0">
-              <a:srgbClr val="000000">
-                <a:alpha val="35000"/>
-              </a:srgbClr>
-            </a:outerShdw>
-          </a:effectLst>
-          <a:scene3d>
-            <a:camera prst="orthographicFront">
-              <a:rot lat="0" lon="0" rev="0"/>
-            </a:camera>
-            <a:lightRig rig="threePt" dir="t">
-              <a:rot lat="0" lon="0" rev="1200000"/>
-            </a:lightRig>
-          </a:scene3d>
-          <a:sp3d>
-            <a:bevelT w="63500" h="25400"/>
-          </a:sp3d>
-        </a:effectStyle>
-      </a:effectStyleLst>
-      <a:bgFillStyleLst>
-        <a:solidFill>
-          <a:schemeClr val="phClr"/>
-        </a:solidFill>
-        <a:gradFill rotWithShape="1">
-          <a:gsLst>
-            <a:gs pos="0">
-              <a:schemeClr val="phClr">
-                <a:tint val="40000"/>
-                <a:satMod val="350000"/>
-              </a:schemeClr>
-            </a:gs>
-            <a:gs pos="40000">
-              <a:schemeClr val="phClr">
-                <a:tint val="45000"/>
-                <a:shade val="99000"/>
-                <a:satMod val="350000"/>
-              </a:schemeClr>
-            </a:gs>
-            <a:gs pos="100000">
-              <a:schemeClr val="phClr">
-                <a:shade val="20000"/>
-                <a:satMod val="255000"/>
-              </a:schemeClr>
-            </a:gs>
-          </a:gsLst>
-          <a:path path="circle">
-            <a:fillToRect l="50000" t="-80000" r="50000" b="180000"/>
-          </a:path>
-        </a:gradFill>
-        <a:gradFill rotWithShape="1">
-          <a:gsLst>
-            <a:gs pos="0">
-              <a:schemeClr val="phClr">
-                <a:tint val="80000"/>
-                <a:satMod val="300000"/>
-              </a:schemeClr>
-            </a:gs>
-            <a:gs pos="100000">
-              <a:schemeClr val="phClr">
-                <a:shade val="30000"/>
-                <a:satMod val="200000"/>
-              </a:schemeClr>
-            </a:gs>
-          </a:gsLst>
-          <a:path path="circle">
-            <a:fillToRect l="50000" t="50000" r="50000" b="50000"/>
-          </a:path>
-        </a:gradFill>
-      </a:bgFillStyleLst>
-    </a:fmtScheme>
-  </a:themeElements>
-  <a:objectDefaults>
-    <a:spDef>
-      <a:spPr/>
-      <a:bodyPr/>
-      <a:lstStyle/>
-      <a:style>
-        <a:lnRef idx="1">
-          <a:schemeClr val="accent1"/>
-        </a:lnRef>
-        <a:fillRef idx="3">
-          <a:schemeClr val="accent1"/>
-        </a:fillRef>
-        <a:effectRef idx="2">
-          <a:schemeClr val="accent1"/>
-        </a:effectRef>
-        <a:fontRef idx="minor">
-          <a:schemeClr val="lt1"/>
-        </a:fontRef>
-      </a:style>
-    </a:spDef>
-    <a:lnDef>
-      <a:spPr/>
-      <a:bodyPr/>
-      <a:lstStyle/>
-      <a:style>
-        <a:lnRef idx="2">
-          <a:schemeClr val="accent1"/>
-        </a:lnRef>
-        <a:fillRef idx="0">
-          <a:schemeClr val="accent1"/>
-        </a:fillRef>
-        <a:effectRef idx="1">
-          <a:schemeClr val="accent1"/>
-        </a:effectRef>
-        <a:fontRef idx="minor">
-          <a:schemeClr val="tx1"/>
-        </a:fontRef>
-      </a:style>
-    </a:lnDef>
-  </a:objectDefaults>
-  <a:extraClrSchemeLst/>
-</a:theme>
 </file>
</xml_diff>